<commit_message>
docs: finale deck — past-air history in the loop, demo checkpoint 1, and appendix A9
</commit_message>
<xml_diff>
--- a/docs/VayuNetra_Pitch.pptx
+++ b/docs/VayuNetra_Pitch.pptx
@@ -21,6 +21,7 @@
     <p:sldId id="269" r:id="rId21"/>
     <p:sldId id="270" r:id="rId22"/>
     <p:sldId id="271" r:id="rId23"/>
+    <p:sldId id="272" r:id="rId24"/>
   </p:sldIdLst>
   <p:sldSz cx="12191695" cy="6858000" type="screen4x3"/>
   <p:notesSz cx="6858000" cy="9144000"/>
@@ -879,7 +880,7 @@
           <a:lstStyle/>
           <a:p>
             <a:r>
-              <a:t>A5 — for deep technical questions on the models. Full numbers, both baselines, failures included.</a:t>
+              <a:t>A9 — for 'can citizens/officers see trends?' Real station readings aggregated per day (SQL); per-cell or per-city; verdict compares the latest week with the week a month earlier; cells without a long station record honestly show the nearest monitored cell and say how far. Works offline too.</a:t>
             </a:r>
           </a:p>
         </p:txBody>
@@ -949,7 +950,7 @@
           <a:lstStyle/>
           <a:p>
             <a:r>
-              <a:t>A6 — for 'can we trust it?' / fairness / liability questions. These are engineering constraints, not values statements.</a:t>
+              <a:t>A5 — for deep technical questions on the models. Full numbers, both baselines, failures included.</a:t>
             </a:r>
           </a:p>
         </p:txBody>
@@ -1019,6 +1020,76 @@
           <a:lstStyle/>
           <a:p>
             <a:r>
+              <a:t>A6 — for 'can we trust it?' / fairness / liability questions. These are engineering constraints, not values statements.</a:t>
+            </a:r>
+          </a:p>
+        </p:txBody>
+      </p:sp>
+      <p:sp>
+        <p:nvSpPr>
+          <p:cNvPr id="4" name="Slide Number Placeholder 3"/>
+          <p:cNvSpPr>
+            <a:spLocks noGrp="1"/>
+          </p:cNvSpPr>
+          <p:nvPr>
+            <p:ph type="sldNum" idx="5" sz="quarter"/>
+          </p:nvPr>
+        </p:nvSpPr>
+        <p:spPr/>
+      </p:sp>
+    </p:spTree>
+  </p:cSld>
+  <p:clrMapOvr>
+    <a:masterClrMapping/>
+  </p:clrMapOvr>
+</p:notes>
+</file>
+
+<file path=ppt/notesSlides/notesSlide17.xml><?xml version="1.0" encoding="utf-8"?>
+<p:notes xmlns:a="http://schemas.openxmlformats.org/drawingml/2006/main" xmlns:p="http://schemas.openxmlformats.org/presentationml/2006/main" xmlns:r="http://schemas.openxmlformats.org/officeDocument/2006/relationships">
+  <p:cSld>
+    <p:spTree>
+      <p:nvGrpSpPr>
+        <p:cNvPr id="1" name=""/>
+        <p:cNvGrpSpPr/>
+        <p:nvPr/>
+      </p:nvGrpSpPr>
+      <p:grpSpPr>
+        <a:xfrm>
+          <a:off x="0" y="0"/>
+          <a:ext cx="0" cy="0"/>
+          <a:chOff x="0" y="0"/>
+          <a:chExt cx="0" cy="0"/>
+        </a:xfrm>
+      </p:grpSpPr>
+      <p:sp>
+        <p:nvSpPr>
+          <p:cNvPr id="2" name="Slide Image Placeholder 1"/>
+          <p:cNvSpPr>
+            <a:spLocks noGrp="1"/>
+          </p:cNvSpPr>
+          <p:nvPr>
+            <p:ph type="sldImg" idx="2"/>
+          </p:nvPr>
+        </p:nvSpPr>
+        <p:spPr/>
+      </p:sp>
+      <p:sp>
+        <p:nvSpPr>
+          <p:cNvPr id="3" name="Notes Placeholder 2"/>
+          <p:cNvSpPr>
+            <a:spLocks noGrp="1"/>
+          </p:cNvSpPr>
+          <p:nvPr>
+            <p:ph type="body" idx="3" sz="quarter"/>
+          </p:nvPr>
+        </p:nvSpPr>
+        <p:spPr/>
+        <p:txBody>
+          <a:bodyPr/>
+          <a:lstStyle/>
+          <a:p>
+            <a:r>
               <a:t>A7 — for 'what does it cost?' / 'how does it scale?' / 'what's next?'</a:t>
             </a:r>
           </a:p>
@@ -1177,7 +1248,7 @@
           <a:p/>
           <a:p>
             <a:r>
-              <a:t>"VayuNetra closes that loop in four steps, on one spatial unit: the city divided into one-square-kilometre cells. TRACE: a machine-learning model attributes the PM2.5 in every cell to traffic, construction, industry or burning — with SHAP evidence, and it ABSTAINS to cited chemical signatures where it lacks skill. It never over-claims. PREDICT: 72-hour forecasts per cell with calibrated uncertainty. ACT: a ranked worklist for officers — every item carries real Sentinel-2 satellite evidence, retrieved regulatory citations, and a draft notice PDF. PROTECT: advisories in four languages — app, Telegram, real IVR phone calls, public displays. Six agents run this end to end; the measured time from signal to cited action is under ten seconds. Abhinav will now show you — live."</a:t>
+              <a:t>"VayuNetra closes that loop in four steps, on one spatial unit: the city divided into one-square-kilometre cells. TRACE: a machine-learning model attributes the PM2.5 in every cell to traffic, construction, industry or burning — with SHAP evidence, and it ABSTAINS to cited chemical signatures where it lacks skill. It never over-claims. PREDICT: 72-hour forecasts per cell with calibrated uncertainty — and every place carries its own past: a year of daily air, so you can see whether it is getting better or worse. ACT: a ranked worklist for officers — every item carries real Sentinel-2 satellite evidence, retrieved regulatory citations, and a draft notice PDF. PROTECT: advisories in four languages — app, Telegram, real IVR phone calls, public displays. Six agents run this end to end; the measured time from signal to cited action is under ten seconds. Abhinav will now show you — live."</a:t>
             </a:r>
           </a:p>
           <a:p/>
@@ -1264,7 +1335,7 @@
           </a:p>
           <a:p>
             <a:r>
-              <a:t>1) BLAME MAP (40s): 'This is Delhi, live. Every hexagon is one square kilometre, coloured by who is to blame.' Click a red cell → Cell Story: place name, traffic share, the green SHAP box — 'the model shows its own evidence and its own R-squared.' Point at the 72-hour outlook.</a:t>
+              <a:t>1) BLAME MAP (45s): 'This is Delhi, live. Every hexagon is one square kilometre, coloured by who is to blame.' Click a red cell → Cell Story: place name, traffic share, the green SHAP box — 'the model shows its own evidence and its own R-squared.' Scroll to PAST AIR: 'and here is this place's own history — worse than a month ago, in plain words.' Point at the 72-hour outlook.</a:t>
             </a:r>
           </a:p>
           <a:p>
@@ -5761,94 +5832,40 @@
         <p:nvPr/>
       </p:nvGrpSpPr>
       <p:grpSpPr/>
-      <p:sp>
-        <p:nvSpPr>
-          <p:cNvPr id="2" name="TextBox 1"/>
-          <p:cNvSpPr txBox="1"/>
-          <p:nvPr/>
-        </p:nvSpPr>
-        <p:spPr>
-          <a:xfrm>
-            <a:off x="502920" y="347472"/>
-            <a:ext cx="11155680" cy="320040"/>
-          </a:xfrm>
-          <a:prstGeom prst="rect">
-            <a:avLst/>
-          </a:prstGeom>
-          <a:noFill/>
-        </p:spPr>
-        <p:txBody>
-          <a:bodyPr wrap="square" anchor="t" lIns="0" rIns="0" tIns="0" bIns="0">
-            <a:spAutoFit/>
-          </a:bodyPr>
-          <a:lstStyle/>
-          <a:p>
-            <a:pPr algn="l">
-              <a:lnSpc>
-                <a:spcPct val="100000"/>
-              </a:lnSpc>
-            </a:pPr>
-            <a:r>
-              <a:rPr sz="1400" b="1" i="0">
-                <a:solidFill>
-                  <a:srgbClr val="059669"/>
-                </a:solidFill>
-                <a:latin typeface="Calibri"/>
-              </a:rPr>
-              <a:t>A5 · MODELS &amp; VALIDATION DETAIL</a:t>
-            </a:r>
-          </a:p>
-        </p:txBody>
-      </p:sp>
-      <p:sp>
-        <p:nvSpPr>
-          <p:cNvPr id="3" name="TextBox 2"/>
-          <p:cNvSpPr txBox="1"/>
-          <p:nvPr/>
-        </p:nvSpPr>
-        <p:spPr>
-          <a:xfrm>
-            <a:off x="502920" y="658368"/>
-            <a:ext cx="11247120" cy="777240"/>
-          </a:xfrm>
-          <a:prstGeom prst="rect">
-            <a:avLst/>
-          </a:prstGeom>
-          <a:noFill/>
-        </p:spPr>
-        <p:txBody>
-          <a:bodyPr wrap="square" anchor="t" lIns="0" rIns="0" tIns="0" bIns="0">
-            <a:spAutoFit/>
-          </a:bodyPr>
-          <a:lstStyle/>
-          <a:p>
-            <a:pPr algn="l">
-              <a:lnSpc>
-                <a:spcPct val="100000"/>
-              </a:lnSpc>
-            </a:pPr>
-            <a:r>
-              <a:rPr sz="2800" b="1" i="0">
-                <a:solidFill>
-                  <a:srgbClr val="0F172A"/>
-                </a:solidFill>
-                <a:latin typeface="Calibri"/>
-              </a:rPr>
-              <a:t>The full numbers, both baselines</a:t>
-            </a:r>
-          </a:p>
-        </p:txBody>
-      </p:sp>
-      <p:sp>
-        <p:nvSpPr>
-          <p:cNvPr id="4" name="Rectangle 3"/>
+      <p:pic>
+        <p:nvPicPr>
+          <p:cNvPr id="2" name="Picture 1" descr="history.jpg"/>
+          <p:cNvPicPr>
+            <a:picLocks noChangeAspect="1"/>
+          </p:cNvPicPr>
+          <p:nvPr/>
+        </p:nvPicPr>
+        <p:blipFill>
+          <a:blip r:embed="rId3"/>
+          <a:stretch>
+            <a:fillRect/>
+          </a:stretch>
+        </p:blipFill>
+        <p:spPr>
+          <a:xfrm>
+            <a:off x="0" y="0"/>
+            <a:ext cx="12191695" cy="6857828"/>
+          </a:xfrm>
+          <a:prstGeom prst="rect">
+            <a:avLst/>
+          </a:prstGeom>
+        </p:spPr>
+      </p:pic>
+      <p:sp>
+        <p:nvSpPr>
+          <p:cNvPr id="3" name="Rectangle 2"/>
           <p:cNvSpPr/>
           <p:nvPr/>
         </p:nvSpPr>
         <p:spPr>
           <a:xfrm>
-            <a:off x="502920" y="1600200"/>
-            <a:ext cx="11155680" cy="566928"/>
+            <a:off x="0" y="6199632"/>
+            <a:ext cx="12191695" cy="658368"/>
           </a:xfrm>
           <a:prstGeom prst="rect">
             <a:avLst/>
@@ -5856,10 +5873,8 @@
           <a:solidFill>
             <a:srgbClr val="1B294A"/>
           </a:solidFill>
-          <a:ln w="9525">
-            <a:solidFill>
-              <a:srgbClr val="E2E8F0"/>
-            </a:solidFill>
+          <a:ln>
+            <a:noFill/>
           </a:ln>
           <a:effectLst/>
         </p:spPr>
@@ -5887,14 +5902,53 @@
       </p:sp>
       <p:sp>
         <p:nvSpPr>
+          <p:cNvPr id="4" name="TextBox 3"/>
+          <p:cNvSpPr txBox="1"/>
+          <p:nvPr/>
+        </p:nvSpPr>
+        <p:spPr>
+          <a:xfrm>
+            <a:off x="502920" y="6254496"/>
+            <a:ext cx="2194560" cy="548640"/>
+          </a:xfrm>
+          <a:prstGeom prst="rect">
+            <a:avLst/>
+          </a:prstGeom>
+          <a:noFill/>
+        </p:spPr>
+        <p:txBody>
+          <a:bodyPr wrap="square" anchor="ctr" lIns="0" rIns="0" tIns="0" bIns="0">
+            <a:spAutoFit/>
+          </a:bodyPr>
+          <a:lstStyle/>
+          <a:p>
+            <a:pPr algn="l">
+              <a:lnSpc>
+                <a:spcPct val="100000"/>
+              </a:lnSpc>
+            </a:pPr>
+            <a:r>
+              <a:rPr sz="1400" b="1" i="0">
+                <a:solidFill>
+                  <a:srgbClr val="6EE7B7"/>
+                </a:solidFill>
+                <a:latin typeface="Calibri"/>
+              </a:rPr>
+              <a:t>A9 · PAST AIR</a:t>
+            </a:r>
+          </a:p>
+        </p:txBody>
+      </p:sp>
+      <p:sp>
+        <p:nvSpPr>
           <p:cNvPr id="5" name="TextBox 4"/>
           <p:cNvSpPr txBox="1"/>
           <p:nvPr/>
         </p:nvSpPr>
         <p:spPr>
           <a:xfrm>
-            <a:off x="685800" y="1600200"/>
-            <a:ext cx="3657600" cy="566928"/>
+            <a:off x="2743200" y="6254496"/>
+            <a:ext cx="8961120" cy="548640"/>
           </a:xfrm>
           <a:prstGeom prst="rect">
             <a:avLst/>
@@ -5909,719 +5963,17 @@
           <a:p>
             <a:pPr algn="l">
               <a:lnSpc>
-                <a:spcPct val="100000"/>
-              </a:lnSpc>
-            </a:pPr>
-            <a:r>
-              <a:rPr sz="1400" b="1" i="0">
+                <a:spcPct val="110000"/>
+              </a:lnSpc>
+            </a:pPr>
+            <a:r>
+              <a:rPr sz="1400" b="0" i="0">
                 <a:solidFill>
                   <a:srgbClr val="FFFFFF"/>
                 </a:solidFill>
                 <a:latin typeface="Calibri"/>
               </a:rPr>
-              <a:t>Forecast skill (24/48/72 h)</a:t>
-            </a:r>
-          </a:p>
-        </p:txBody>
-      </p:sp>
-      <p:sp>
-        <p:nvSpPr>
-          <p:cNvPr id="6" name="TextBox 5"/>
-          <p:cNvSpPr txBox="1"/>
-          <p:nvPr/>
-        </p:nvSpPr>
-        <p:spPr>
-          <a:xfrm>
-            <a:off x="4709160" y="1600200"/>
-            <a:ext cx="3200400" cy="566928"/>
-          </a:xfrm>
-          <a:prstGeom prst="rect">
-            <a:avLst/>
-          </a:prstGeom>
-          <a:noFill/>
-        </p:spPr>
-        <p:txBody>
-          <a:bodyPr wrap="square" anchor="ctr" lIns="0" rIns="0" tIns="0" bIns="0">
-            <a:spAutoFit/>
-          </a:bodyPr>
-          <a:lstStyle/>
-          <a:p>
-            <a:pPr algn="l">
-              <a:lnSpc>
-                <a:spcPct val="100000"/>
-              </a:lnSpc>
-            </a:pPr>
-            <a:r>
-              <a:rPr sz="1400" b="1" i="0">
-                <a:solidFill>
-                  <a:srgbClr val="FFFFFF"/>
-                </a:solidFill>
-                <a:latin typeface="Calibri"/>
-              </a:rPr>
-              <a:t>vs persistence</a:t>
-            </a:r>
-          </a:p>
-        </p:txBody>
-      </p:sp>
-      <p:sp>
-        <p:nvSpPr>
-          <p:cNvPr id="7" name="TextBox 6"/>
-          <p:cNvSpPr txBox="1"/>
-          <p:nvPr/>
-        </p:nvSpPr>
-        <p:spPr>
-          <a:xfrm>
-            <a:off x="8275319" y="1600200"/>
-            <a:ext cx="3200400" cy="566928"/>
-          </a:xfrm>
-          <a:prstGeom prst="rect">
-            <a:avLst/>
-          </a:prstGeom>
-          <a:noFill/>
-        </p:spPr>
-        <p:txBody>
-          <a:bodyPr wrap="square" anchor="ctr" lIns="0" rIns="0" tIns="0" bIns="0">
-            <a:spAutoFit/>
-          </a:bodyPr>
-          <a:lstStyle/>
-          <a:p>
-            <a:pPr algn="l">
-              <a:lnSpc>
-                <a:spcPct val="100000"/>
-              </a:lnSpc>
-            </a:pPr>
-            <a:r>
-              <a:rPr sz="1400" b="1" i="0">
-                <a:solidFill>
-                  <a:srgbClr val="FFFFFF"/>
-                </a:solidFill>
-                <a:latin typeface="Calibri"/>
-              </a:rPr>
-              <a:t>vs climatology</a:t>
-            </a:r>
-          </a:p>
-        </p:txBody>
-      </p:sp>
-      <p:sp>
-        <p:nvSpPr>
-          <p:cNvPr id="8" name="Rectangle 7"/>
-          <p:cNvSpPr/>
-          <p:nvPr/>
-        </p:nvSpPr>
-        <p:spPr>
-          <a:xfrm>
-            <a:off x="502920" y="2167128"/>
-            <a:ext cx="11155680" cy="566928"/>
-          </a:xfrm>
-          <a:prstGeom prst="rect">
-            <a:avLst/>
-          </a:prstGeom>
-          <a:solidFill>
-            <a:srgbClr val="FFFFFF"/>
-          </a:solidFill>
-          <a:ln w="9525">
-            <a:solidFill>
-              <a:srgbClr val="E2E8F0"/>
-            </a:solidFill>
-          </a:ln>
-          <a:effectLst/>
-        </p:spPr>
-        <p:style>
-          <a:lnRef idx="1">
-            <a:schemeClr val="accent1"/>
-          </a:lnRef>
-          <a:fillRef idx="3">
-            <a:schemeClr val="accent1"/>
-          </a:fillRef>
-          <a:effectRef idx="2">
-            <a:schemeClr val="accent1"/>
-          </a:effectRef>
-          <a:fontRef idx="minor">
-            <a:schemeClr val="lt1"/>
-          </a:fontRef>
-        </p:style>
-        <p:txBody>
-          <a:bodyPr rtlCol="0" anchor="ctr"/>
-          <a:lstStyle/>
-          <a:p>
-            <a:pPr algn="ctr"/>
-          </a:p>
-        </p:txBody>
-      </p:sp>
-      <p:sp>
-        <p:nvSpPr>
-          <p:cNvPr id="9" name="TextBox 8"/>
-          <p:cNvSpPr txBox="1"/>
-          <p:nvPr/>
-        </p:nvSpPr>
-        <p:spPr>
-          <a:xfrm>
-            <a:off x="685800" y="2167128"/>
-            <a:ext cx="3657600" cy="566928"/>
-          </a:xfrm>
-          <a:prstGeom prst="rect">
-            <a:avLst/>
-          </a:prstGeom>
-          <a:noFill/>
-        </p:spPr>
-        <p:txBody>
-          <a:bodyPr wrap="square" anchor="ctr" lIns="0" rIns="0" tIns="0" bIns="0">
-            <a:spAutoFit/>
-          </a:bodyPr>
-          <a:lstStyle/>
-          <a:p>
-            <a:pPr algn="l">
-              <a:lnSpc>
-                <a:spcPct val="100000"/>
-              </a:lnSpc>
-            </a:pPr>
-            <a:r>
-              <a:rPr sz="1400" b="1" i="0">
-                <a:solidFill>
-                  <a:srgbClr val="475569"/>
-                </a:solidFill>
-                <a:latin typeface="Calibri"/>
-              </a:rPr>
-              <a:t>Delhi (n≈27k)</a:t>
-            </a:r>
-          </a:p>
-        </p:txBody>
-      </p:sp>
-      <p:sp>
-        <p:nvSpPr>
-          <p:cNvPr id="10" name="TextBox 9"/>
-          <p:cNvSpPr txBox="1"/>
-          <p:nvPr/>
-        </p:nvSpPr>
-        <p:spPr>
-          <a:xfrm>
-            <a:off x="4709160" y="2167128"/>
-            <a:ext cx="3200400" cy="566928"/>
-          </a:xfrm>
-          <a:prstGeom prst="rect">
-            <a:avLst/>
-          </a:prstGeom>
-          <a:noFill/>
-        </p:spPr>
-        <p:txBody>
-          <a:bodyPr wrap="square" anchor="ctr" lIns="0" rIns="0" tIns="0" bIns="0">
-            <a:spAutoFit/>
-          </a:bodyPr>
-          <a:lstStyle/>
-          <a:p>
-            <a:pPr algn="l">
-              <a:lnSpc>
-                <a:spcPct val="100000"/>
-              </a:lnSpc>
-            </a:pPr>
-            <a:r>
-              <a:rPr sz="1400" b="0" i="0">
-                <a:solidFill>
-                  <a:srgbClr val="0F172A"/>
-                </a:solidFill>
-                <a:latin typeface="Calibri"/>
-              </a:rPr>
-              <a:t>+4% / +4% / +8%</a:t>
-            </a:r>
-          </a:p>
-        </p:txBody>
-      </p:sp>
-      <p:sp>
-        <p:nvSpPr>
-          <p:cNvPr id="11" name="TextBox 10"/>
-          <p:cNvSpPr txBox="1"/>
-          <p:nvPr/>
-        </p:nvSpPr>
-        <p:spPr>
-          <a:xfrm>
-            <a:off x="8275319" y="2167128"/>
-            <a:ext cx="3200400" cy="566928"/>
-          </a:xfrm>
-          <a:prstGeom prst="rect">
-            <a:avLst/>
-          </a:prstGeom>
-          <a:noFill/>
-        </p:spPr>
-        <p:txBody>
-          <a:bodyPr wrap="square" anchor="ctr" lIns="0" rIns="0" tIns="0" bIns="0">
-            <a:spAutoFit/>
-          </a:bodyPr>
-          <a:lstStyle/>
-          <a:p>
-            <a:pPr algn="l">
-              <a:lnSpc>
-                <a:spcPct val="100000"/>
-              </a:lnSpc>
-            </a:pPr>
-            <a:r>
-              <a:rPr sz="1400" b="0" i="0">
-                <a:solidFill>
-                  <a:srgbClr val="0F172A"/>
-                </a:solidFill>
-                <a:latin typeface="Calibri"/>
-              </a:rPr>
-              <a:t>+31% / +18% / +16%</a:t>
-            </a:r>
-          </a:p>
-        </p:txBody>
-      </p:sp>
-      <p:sp>
-        <p:nvSpPr>
-          <p:cNvPr id="12" name="Rectangle 11"/>
-          <p:cNvSpPr/>
-          <p:nvPr/>
-        </p:nvSpPr>
-        <p:spPr>
-          <a:xfrm>
-            <a:off x="502920" y="2734056"/>
-            <a:ext cx="11155680" cy="566928"/>
-          </a:xfrm>
-          <a:prstGeom prst="rect">
-            <a:avLst/>
-          </a:prstGeom>
-          <a:solidFill>
-            <a:srgbClr val="F1F5F9"/>
-          </a:solidFill>
-          <a:ln w="9525">
-            <a:solidFill>
-              <a:srgbClr val="E2E8F0"/>
-            </a:solidFill>
-          </a:ln>
-          <a:effectLst/>
-        </p:spPr>
-        <p:style>
-          <a:lnRef idx="1">
-            <a:schemeClr val="accent1"/>
-          </a:lnRef>
-          <a:fillRef idx="3">
-            <a:schemeClr val="accent1"/>
-          </a:fillRef>
-          <a:effectRef idx="2">
-            <a:schemeClr val="accent1"/>
-          </a:effectRef>
-          <a:fontRef idx="minor">
-            <a:schemeClr val="lt1"/>
-          </a:fontRef>
-        </p:style>
-        <p:txBody>
-          <a:bodyPr rtlCol="0" anchor="ctr"/>
-          <a:lstStyle/>
-          <a:p>
-            <a:pPr algn="ctr"/>
-          </a:p>
-        </p:txBody>
-      </p:sp>
-      <p:sp>
-        <p:nvSpPr>
-          <p:cNvPr id="13" name="TextBox 12"/>
-          <p:cNvSpPr txBox="1"/>
-          <p:nvPr/>
-        </p:nvSpPr>
-        <p:spPr>
-          <a:xfrm>
-            <a:off x="685800" y="2734056"/>
-            <a:ext cx="3657600" cy="566928"/>
-          </a:xfrm>
-          <a:prstGeom prst="rect">
-            <a:avLst/>
-          </a:prstGeom>
-          <a:noFill/>
-        </p:spPr>
-        <p:txBody>
-          <a:bodyPr wrap="square" anchor="ctr" lIns="0" rIns="0" tIns="0" bIns="0">
-            <a:spAutoFit/>
-          </a:bodyPr>
-          <a:lstStyle/>
-          <a:p>
-            <a:pPr algn="l">
-              <a:lnSpc>
-                <a:spcPct val="100000"/>
-              </a:lnSpc>
-            </a:pPr>
-            <a:r>
-              <a:rPr sz="1400" b="1" i="0">
-                <a:solidFill>
-                  <a:srgbClr val="475569"/>
-                </a:solidFill>
-                <a:latin typeface="Calibri"/>
-              </a:rPr>
-              <a:t>Bengaluru</a:t>
-            </a:r>
-          </a:p>
-        </p:txBody>
-      </p:sp>
-      <p:sp>
-        <p:nvSpPr>
-          <p:cNvPr id="14" name="TextBox 13"/>
-          <p:cNvSpPr txBox="1"/>
-          <p:nvPr/>
-        </p:nvSpPr>
-        <p:spPr>
-          <a:xfrm>
-            <a:off x="4709160" y="2734056"/>
-            <a:ext cx="3200400" cy="566928"/>
-          </a:xfrm>
-          <a:prstGeom prst="rect">
-            <a:avLst/>
-          </a:prstGeom>
-          <a:noFill/>
-        </p:spPr>
-        <p:txBody>
-          <a:bodyPr wrap="square" anchor="ctr" lIns="0" rIns="0" tIns="0" bIns="0">
-            <a:spAutoFit/>
-          </a:bodyPr>
-          <a:lstStyle/>
-          <a:p>
-            <a:pPr algn="l">
-              <a:lnSpc>
-                <a:spcPct val="100000"/>
-              </a:lnSpc>
-            </a:pPr>
-            <a:r>
-              <a:rPr sz="1400" b="0" i="0">
-                <a:solidFill>
-                  <a:srgbClr val="0F172A"/>
-                </a:solidFill>
-                <a:latin typeface="Calibri"/>
-              </a:rPr>
-              <a:t>+15% / +17% / +9%</a:t>
-            </a:r>
-          </a:p>
-        </p:txBody>
-      </p:sp>
-      <p:sp>
-        <p:nvSpPr>
-          <p:cNvPr id="15" name="TextBox 14"/>
-          <p:cNvSpPr txBox="1"/>
-          <p:nvPr/>
-        </p:nvSpPr>
-        <p:spPr>
-          <a:xfrm>
-            <a:off x="8275319" y="2734056"/>
-            <a:ext cx="3200400" cy="566928"/>
-          </a:xfrm>
-          <a:prstGeom prst="rect">
-            <a:avLst/>
-          </a:prstGeom>
-          <a:noFill/>
-        </p:spPr>
-        <p:txBody>
-          <a:bodyPr wrap="square" anchor="ctr" lIns="0" rIns="0" tIns="0" bIns="0">
-            <a:spAutoFit/>
-          </a:bodyPr>
-          <a:lstStyle/>
-          <a:p>
-            <a:pPr algn="l">
-              <a:lnSpc>
-                <a:spcPct val="100000"/>
-              </a:lnSpc>
-            </a:pPr>
-            <a:r>
-              <a:rPr sz="1400" b="0" i="0">
-                <a:solidFill>
-                  <a:srgbClr val="0F172A"/>
-                </a:solidFill>
-                <a:latin typeface="Calibri"/>
-              </a:rPr>
-              <a:t>+14% / +5% / −7%</a:t>
-            </a:r>
-          </a:p>
-        </p:txBody>
-      </p:sp>
-      <p:sp>
-        <p:nvSpPr>
-          <p:cNvPr id="16" name="Rectangle 15"/>
-          <p:cNvSpPr/>
-          <p:nvPr/>
-        </p:nvSpPr>
-        <p:spPr>
-          <a:xfrm>
-            <a:off x="502920" y="3300984"/>
-            <a:ext cx="11155680" cy="566928"/>
-          </a:xfrm>
-          <a:prstGeom prst="rect">
-            <a:avLst/>
-          </a:prstGeom>
-          <a:solidFill>
-            <a:srgbClr val="FFFFFF"/>
-          </a:solidFill>
-          <a:ln w="9525">
-            <a:solidFill>
-              <a:srgbClr val="E2E8F0"/>
-            </a:solidFill>
-          </a:ln>
-          <a:effectLst/>
-        </p:spPr>
-        <p:style>
-          <a:lnRef idx="1">
-            <a:schemeClr val="accent1"/>
-          </a:lnRef>
-          <a:fillRef idx="3">
-            <a:schemeClr val="accent1"/>
-          </a:fillRef>
-          <a:effectRef idx="2">
-            <a:schemeClr val="accent1"/>
-          </a:effectRef>
-          <a:fontRef idx="minor">
-            <a:schemeClr val="lt1"/>
-          </a:fontRef>
-        </p:style>
-        <p:txBody>
-          <a:bodyPr rtlCol="0" anchor="ctr"/>
-          <a:lstStyle/>
-          <a:p>
-            <a:pPr algn="ctr"/>
-          </a:p>
-        </p:txBody>
-      </p:sp>
-      <p:sp>
-        <p:nvSpPr>
-          <p:cNvPr id="17" name="TextBox 16"/>
-          <p:cNvSpPr txBox="1"/>
-          <p:nvPr/>
-        </p:nvSpPr>
-        <p:spPr>
-          <a:xfrm>
-            <a:off x="685800" y="3300984"/>
-            <a:ext cx="3657600" cy="566928"/>
-          </a:xfrm>
-          <a:prstGeom prst="rect">
-            <a:avLst/>
-          </a:prstGeom>
-          <a:noFill/>
-        </p:spPr>
-        <p:txBody>
-          <a:bodyPr wrap="square" anchor="ctr" lIns="0" rIns="0" tIns="0" bIns="0">
-            <a:spAutoFit/>
-          </a:bodyPr>
-          <a:lstStyle/>
-          <a:p>
-            <a:pPr algn="l">
-              <a:lnSpc>
-                <a:spcPct val="100000"/>
-              </a:lnSpc>
-            </a:pPr>
-            <a:r>
-              <a:rPr sz="1400" b="1" i="0">
-                <a:solidFill>
-                  <a:srgbClr val="475569"/>
-                </a:solidFill>
-                <a:latin typeface="Calibri"/>
-              </a:rPr>
-              <a:t>Mumbai</a:t>
-            </a:r>
-          </a:p>
-        </p:txBody>
-      </p:sp>
-      <p:sp>
-        <p:nvSpPr>
-          <p:cNvPr id="18" name="TextBox 17"/>
-          <p:cNvSpPr txBox="1"/>
-          <p:nvPr/>
-        </p:nvSpPr>
-        <p:spPr>
-          <a:xfrm>
-            <a:off x="4709160" y="3300984"/>
-            <a:ext cx="3200400" cy="566928"/>
-          </a:xfrm>
-          <a:prstGeom prst="rect">
-            <a:avLst/>
-          </a:prstGeom>
-          <a:noFill/>
-        </p:spPr>
-        <p:txBody>
-          <a:bodyPr wrap="square" anchor="ctr" lIns="0" rIns="0" tIns="0" bIns="0">
-            <a:spAutoFit/>
-          </a:bodyPr>
-          <a:lstStyle/>
-          <a:p>
-            <a:pPr algn="l">
-              <a:lnSpc>
-                <a:spcPct val="100000"/>
-              </a:lnSpc>
-            </a:pPr>
-            <a:r>
-              <a:rPr sz="1400" b="0" i="0">
-                <a:solidFill>
-                  <a:srgbClr val="0F172A"/>
-                </a:solidFill>
-                <a:latin typeface="Calibri"/>
-              </a:rPr>
-              <a:t>+15% / +18% / +30%</a:t>
-            </a:r>
-          </a:p>
-        </p:txBody>
-      </p:sp>
-      <p:sp>
-        <p:nvSpPr>
-          <p:cNvPr id="19" name="TextBox 18"/>
-          <p:cNvSpPr txBox="1"/>
-          <p:nvPr/>
-        </p:nvSpPr>
-        <p:spPr>
-          <a:xfrm>
-            <a:off x="8275319" y="3300984"/>
-            <a:ext cx="3200400" cy="566928"/>
-          </a:xfrm>
-          <a:prstGeom prst="rect">
-            <a:avLst/>
-          </a:prstGeom>
-          <a:noFill/>
-        </p:spPr>
-        <p:txBody>
-          <a:bodyPr wrap="square" anchor="ctr" lIns="0" rIns="0" tIns="0" bIns="0">
-            <a:spAutoFit/>
-          </a:bodyPr>
-          <a:lstStyle/>
-          <a:p>
-            <a:pPr algn="l">
-              <a:lnSpc>
-                <a:spcPct val="100000"/>
-              </a:lnSpc>
-            </a:pPr>
-            <a:r>
-              <a:rPr sz="1400" b="0" i="0">
-                <a:solidFill>
-                  <a:srgbClr val="0F172A"/>
-                </a:solidFill>
-                <a:latin typeface="Calibri"/>
-              </a:rPr>
-              <a:t>+3% / +3% / +4%</a:t>
-            </a:r>
-          </a:p>
-        </p:txBody>
-      </p:sp>
-      <p:sp>
-        <p:nvSpPr>
-          <p:cNvPr id="20" name="TextBox 19"/>
-          <p:cNvSpPr txBox="1"/>
-          <p:nvPr/>
-        </p:nvSpPr>
-        <p:spPr>
-          <a:xfrm>
-            <a:off x="502920" y="4114800"/>
-            <a:ext cx="11155680" cy="2103120"/>
-          </a:xfrm>
-          <a:prstGeom prst="rect">
-            <a:avLst/>
-          </a:prstGeom>
-          <a:noFill/>
-        </p:spPr>
-        <p:txBody>
-          <a:bodyPr wrap="square" anchor="t" lIns="0" rIns="0" tIns="0" bIns="0">
-            <a:spAutoFit/>
-          </a:bodyPr>
-          <a:lstStyle/>
-          <a:p>
-            <a:pPr algn="l">
-              <a:lnSpc>
-                <a:spcPct val="120000"/>
-              </a:lnSpc>
-              <a:spcAft>
-                <a:spcPts val="600"/>
-              </a:spcAft>
-            </a:pPr>
-            <a:r>
-              <a:rPr sz="1450" b="1" i="0">
-                <a:solidFill>
-                  <a:srgbClr val="0F172A"/>
-                </a:solidFill>
-                <a:latin typeface="Calibri"/>
-              </a:rPr>
-              <a:t>Attribution </a:t>
-            </a:r>
-            <a:r>
-              <a:rPr sz="1450" b="0" i="0">
-                <a:solidFill>
-                  <a:srgbClr val="475569"/>
-                </a:solidFill>
-                <a:latin typeface="Calibri"/>
-              </a:rPr>
-              <a:t>— LightGBM + SHAP blended with chemical-signature priors; abstains below an out-of-sample R² gate of 0.15. Cross-checked vs inventories (cosine 0.92/0.88/0.79); traffic SHAP 2.30× higher in IST rush hours with weather controlled.</a:t>
-            </a:r>
-          </a:p>
-          <a:p>
-            <a:pPr algn="l">
-              <a:lnSpc>
-                <a:spcPct val="120000"/>
-              </a:lnSpc>
-              <a:spcAft>
-                <a:spcPts val="600"/>
-              </a:spcAft>
-            </a:pPr>
-            <a:r>
-              <a:rPr sz="1450" b="1" i="0">
-                <a:solidFill>
-                  <a:srgbClr val="0F172A"/>
-                </a:solidFill>
-                <a:latin typeface="Calibri"/>
-              </a:rPr>
-              <a:t>Uncertainty </a:t>
-            </a:r>
-            <a:r>
-              <a:rPr sz="1450" b="0" i="0">
-                <a:solidFill>
-                  <a:srgbClr val="475569"/>
-                </a:solidFill>
-                <a:latin typeface="Calibri"/>
-              </a:rPr>
-              <a:t>— raw intervals under-covered (48–63% vs nominal 80%); fixed with conformalised quantile regression → 75–80% measured coverage.</a:t>
-            </a:r>
-          </a:p>
-          <a:p>
-            <a:pPr algn="l">
-              <a:lnSpc>
-                <a:spcPct val="120000"/>
-              </a:lnSpc>
-              <a:spcAft>
-                <a:spcPts val="600"/>
-              </a:spcAft>
-            </a:pPr>
-            <a:r>
-              <a:rPr sz="1450" b="1" i="0">
-                <a:solidFill>
-                  <a:srgbClr val="0F172A"/>
-                </a:solidFill>
-                <a:latin typeface="Calibri"/>
-              </a:rPr>
-              <a:t>Model selection </a:t>
-            </a:r>
-            <a:r>
-              <a:rPr sz="1450" b="0" i="0">
-                <a:solidFill>
-                  <a:srgbClr val="475569"/>
-                </a:solidFill>
-                <a:latin typeface="Calibri"/>
-              </a:rPr>
-              <a:t>— Temporal Fusion Transformer trained on GPU and rejected: LightGBM won held-out skill in every launch city. The notebook keeps the failure.</a:t>
-            </a:r>
-          </a:p>
-          <a:p>
-            <a:pPr algn="l">
-              <a:lnSpc>
-                <a:spcPct val="120000"/>
-              </a:lnSpc>
-              <a:spcAft>
-                <a:spcPts val="600"/>
-              </a:spcAft>
-            </a:pPr>
-            <a:r>
-              <a:rPr sz="1450" b="1" i="0">
-                <a:solidFill>
-                  <a:srgbClr val="0F172A"/>
-                </a:solidFill>
-                <a:latin typeface="Calibri"/>
-              </a:rPr>
-              <a:t>Satellite detection </a:t>
-            </a:r>
-            <a:r>
-              <a:rPr sz="1450" b="0" i="0">
-                <a:solidFill>
-                  <a:srgbClr val="475569"/>
-                </a:solidFill>
-                <a:latin typeface="Calibri"/>
-              </a:rPr>
-              <a:t>— currently a labelled Earth-Engine heuristic (NDVI drop → construction, FIRMS thermal → burning); the U-Net CV model is in training and drops into the same schema.</a:t>
+              <a:t>Every place carries its own history: daily PM2.5 over the CPCB colour bands, 30 days to a year, with a one-line verdict anyone can read. Delhi's real winter smog season — 400+ µg/m³ in Nov–Dec — against the monsoon.</a:t>
             </a:r>
           </a:p>
         </p:txBody>
@@ -6678,7 +6030,7 @@
                 </a:solidFill>
                 <a:latin typeface="Calibri"/>
               </a:rPr>
-              <a:t>A6 · HONESTY &amp; FAIRNESS</a:t>
+              <a:t>A5 · MODELS &amp; VALIDATION DETAIL</a:t>
             </a:r>
           </a:p>
         </p:txBody>
@@ -6717,26 +6069,350 @@
                 </a:solidFill>
                 <a:latin typeface="Calibri"/>
               </a:rPr>
-              <a:t>Honest by construction</a:t>
-            </a:r>
-          </a:p>
-        </p:txBody>
-      </p:sp>
-      <p:sp>
-        <p:nvSpPr>
-          <p:cNvPr id="4" name="Rounded Rectangle 3"/>
+              <a:t>The full numbers, both baselines</a:t>
+            </a:r>
+          </a:p>
+        </p:txBody>
+      </p:sp>
+      <p:sp>
+        <p:nvSpPr>
+          <p:cNvPr id="4" name="Rectangle 3"/>
           <p:cNvSpPr/>
           <p:nvPr/>
         </p:nvSpPr>
         <p:spPr>
           <a:xfrm>
-            <a:off x="502920" y="1645920"/>
-            <a:ext cx="5596128" cy="1371600"/>
-          </a:xfrm>
-          <a:prstGeom prst="roundRect">
-            <a:avLst>
-              <a:gd name="adj" fmla="val 8000"/>
-            </a:avLst>
+            <a:off x="502920" y="1600200"/>
+            <a:ext cx="11155680" cy="566928"/>
+          </a:xfrm>
+          <a:prstGeom prst="rect">
+            <a:avLst/>
+          </a:prstGeom>
+          <a:solidFill>
+            <a:srgbClr val="1B294A"/>
+          </a:solidFill>
+          <a:ln w="9525">
+            <a:solidFill>
+              <a:srgbClr val="E2E8F0"/>
+            </a:solidFill>
+          </a:ln>
+          <a:effectLst/>
+        </p:spPr>
+        <p:style>
+          <a:lnRef idx="1">
+            <a:schemeClr val="accent1"/>
+          </a:lnRef>
+          <a:fillRef idx="3">
+            <a:schemeClr val="accent1"/>
+          </a:fillRef>
+          <a:effectRef idx="2">
+            <a:schemeClr val="accent1"/>
+          </a:effectRef>
+          <a:fontRef idx="minor">
+            <a:schemeClr val="lt1"/>
+          </a:fontRef>
+        </p:style>
+        <p:txBody>
+          <a:bodyPr rtlCol="0" anchor="ctr"/>
+          <a:lstStyle/>
+          <a:p>
+            <a:pPr algn="ctr"/>
+          </a:p>
+        </p:txBody>
+      </p:sp>
+      <p:sp>
+        <p:nvSpPr>
+          <p:cNvPr id="5" name="TextBox 4"/>
+          <p:cNvSpPr txBox="1"/>
+          <p:nvPr/>
+        </p:nvSpPr>
+        <p:spPr>
+          <a:xfrm>
+            <a:off x="685800" y="1600200"/>
+            <a:ext cx="3657600" cy="566928"/>
+          </a:xfrm>
+          <a:prstGeom prst="rect">
+            <a:avLst/>
+          </a:prstGeom>
+          <a:noFill/>
+        </p:spPr>
+        <p:txBody>
+          <a:bodyPr wrap="square" anchor="ctr" lIns="0" rIns="0" tIns="0" bIns="0">
+            <a:spAutoFit/>
+          </a:bodyPr>
+          <a:lstStyle/>
+          <a:p>
+            <a:pPr algn="l">
+              <a:lnSpc>
+                <a:spcPct val="100000"/>
+              </a:lnSpc>
+            </a:pPr>
+            <a:r>
+              <a:rPr sz="1400" b="1" i="0">
+                <a:solidFill>
+                  <a:srgbClr val="FFFFFF"/>
+                </a:solidFill>
+                <a:latin typeface="Calibri"/>
+              </a:rPr>
+              <a:t>Forecast skill (24/48/72 h)</a:t>
+            </a:r>
+          </a:p>
+        </p:txBody>
+      </p:sp>
+      <p:sp>
+        <p:nvSpPr>
+          <p:cNvPr id="6" name="TextBox 5"/>
+          <p:cNvSpPr txBox="1"/>
+          <p:nvPr/>
+        </p:nvSpPr>
+        <p:spPr>
+          <a:xfrm>
+            <a:off x="4709160" y="1600200"/>
+            <a:ext cx="3200400" cy="566928"/>
+          </a:xfrm>
+          <a:prstGeom prst="rect">
+            <a:avLst/>
+          </a:prstGeom>
+          <a:noFill/>
+        </p:spPr>
+        <p:txBody>
+          <a:bodyPr wrap="square" anchor="ctr" lIns="0" rIns="0" tIns="0" bIns="0">
+            <a:spAutoFit/>
+          </a:bodyPr>
+          <a:lstStyle/>
+          <a:p>
+            <a:pPr algn="l">
+              <a:lnSpc>
+                <a:spcPct val="100000"/>
+              </a:lnSpc>
+            </a:pPr>
+            <a:r>
+              <a:rPr sz="1400" b="1" i="0">
+                <a:solidFill>
+                  <a:srgbClr val="FFFFFF"/>
+                </a:solidFill>
+                <a:latin typeface="Calibri"/>
+              </a:rPr>
+              <a:t>vs persistence</a:t>
+            </a:r>
+          </a:p>
+        </p:txBody>
+      </p:sp>
+      <p:sp>
+        <p:nvSpPr>
+          <p:cNvPr id="7" name="TextBox 6"/>
+          <p:cNvSpPr txBox="1"/>
+          <p:nvPr/>
+        </p:nvSpPr>
+        <p:spPr>
+          <a:xfrm>
+            <a:off x="8275319" y="1600200"/>
+            <a:ext cx="3200400" cy="566928"/>
+          </a:xfrm>
+          <a:prstGeom prst="rect">
+            <a:avLst/>
+          </a:prstGeom>
+          <a:noFill/>
+        </p:spPr>
+        <p:txBody>
+          <a:bodyPr wrap="square" anchor="ctr" lIns="0" rIns="0" tIns="0" bIns="0">
+            <a:spAutoFit/>
+          </a:bodyPr>
+          <a:lstStyle/>
+          <a:p>
+            <a:pPr algn="l">
+              <a:lnSpc>
+                <a:spcPct val="100000"/>
+              </a:lnSpc>
+            </a:pPr>
+            <a:r>
+              <a:rPr sz="1400" b="1" i="0">
+                <a:solidFill>
+                  <a:srgbClr val="FFFFFF"/>
+                </a:solidFill>
+                <a:latin typeface="Calibri"/>
+              </a:rPr>
+              <a:t>vs climatology</a:t>
+            </a:r>
+          </a:p>
+        </p:txBody>
+      </p:sp>
+      <p:sp>
+        <p:nvSpPr>
+          <p:cNvPr id="8" name="Rectangle 7"/>
+          <p:cNvSpPr/>
+          <p:nvPr/>
+        </p:nvSpPr>
+        <p:spPr>
+          <a:xfrm>
+            <a:off x="502920" y="2167128"/>
+            <a:ext cx="11155680" cy="566928"/>
+          </a:xfrm>
+          <a:prstGeom prst="rect">
+            <a:avLst/>
+          </a:prstGeom>
+          <a:solidFill>
+            <a:srgbClr val="FFFFFF"/>
+          </a:solidFill>
+          <a:ln w="9525">
+            <a:solidFill>
+              <a:srgbClr val="E2E8F0"/>
+            </a:solidFill>
+          </a:ln>
+          <a:effectLst/>
+        </p:spPr>
+        <p:style>
+          <a:lnRef idx="1">
+            <a:schemeClr val="accent1"/>
+          </a:lnRef>
+          <a:fillRef idx="3">
+            <a:schemeClr val="accent1"/>
+          </a:fillRef>
+          <a:effectRef idx="2">
+            <a:schemeClr val="accent1"/>
+          </a:effectRef>
+          <a:fontRef idx="minor">
+            <a:schemeClr val="lt1"/>
+          </a:fontRef>
+        </p:style>
+        <p:txBody>
+          <a:bodyPr rtlCol="0" anchor="ctr"/>
+          <a:lstStyle/>
+          <a:p>
+            <a:pPr algn="ctr"/>
+          </a:p>
+        </p:txBody>
+      </p:sp>
+      <p:sp>
+        <p:nvSpPr>
+          <p:cNvPr id="9" name="TextBox 8"/>
+          <p:cNvSpPr txBox="1"/>
+          <p:nvPr/>
+        </p:nvSpPr>
+        <p:spPr>
+          <a:xfrm>
+            <a:off x="685800" y="2167128"/>
+            <a:ext cx="3657600" cy="566928"/>
+          </a:xfrm>
+          <a:prstGeom prst="rect">
+            <a:avLst/>
+          </a:prstGeom>
+          <a:noFill/>
+        </p:spPr>
+        <p:txBody>
+          <a:bodyPr wrap="square" anchor="ctr" lIns="0" rIns="0" tIns="0" bIns="0">
+            <a:spAutoFit/>
+          </a:bodyPr>
+          <a:lstStyle/>
+          <a:p>
+            <a:pPr algn="l">
+              <a:lnSpc>
+                <a:spcPct val="100000"/>
+              </a:lnSpc>
+            </a:pPr>
+            <a:r>
+              <a:rPr sz="1400" b="1" i="0">
+                <a:solidFill>
+                  <a:srgbClr val="475569"/>
+                </a:solidFill>
+                <a:latin typeface="Calibri"/>
+              </a:rPr>
+              <a:t>Delhi (n≈27k)</a:t>
+            </a:r>
+          </a:p>
+        </p:txBody>
+      </p:sp>
+      <p:sp>
+        <p:nvSpPr>
+          <p:cNvPr id="10" name="TextBox 9"/>
+          <p:cNvSpPr txBox="1"/>
+          <p:nvPr/>
+        </p:nvSpPr>
+        <p:spPr>
+          <a:xfrm>
+            <a:off x="4709160" y="2167128"/>
+            <a:ext cx="3200400" cy="566928"/>
+          </a:xfrm>
+          <a:prstGeom prst="rect">
+            <a:avLst/>
+          </a:prstGeom>
+          <a:noFill/>
+        </p:spPr>
+        <p:txBody>
+          <a:bodyPr wrap="square" anchor="ctr" lIns="0" rIns="0" tIns="0" bIns="0">
+            <a:spAutoFit/>
+          </a:bodyPr>
+          <a:lstStyle/>
+          <a:p>
+            <a:pPr algn="l">
+              <a:lnSpc>
+                <a:spcPct val="100000"/>
+              </a:lnSpc>
+            </a:pPr>
+            <a:r>
+              <a:rPr sz="1400" b="0" i="0">
+                <a:solidFill>
+                  <a:srgbClr val="0F172A"/>
+                </a:solidFill>
+                <a:latin typeface="Calibri"/>
+              </a:rPr>
+              <a:t>+4% / +4% / +8%</a:t>
+            </a:r>
+          </a:p>
+        </p:txBody>
+      </p:sp>
+      <p:sp>
+        <p:nvSpPr>
+          <p:cNvPr id="11" name="TextBox 10"/>
+          <p:cNvSpPr txBox="1"/>
+          <p:nvPr/>
+        </p:nvSpPr>
+        <p:spPr>
+          <a:xfrm>
+            <a:off x="8275319" y="2167128"/>
+            <a:ext cx="3200400" cy="566928"/>
+          </a:xfrm>
+          <a:prstGeom prst="rect">
+            <a:avLst/>
+          </a:prstGeom>
+          <a:noFill/>
+        </p:spPr>
+        <p:txBody>
+          <a:bodyPr wrap="square" anchor="ctr" lIns="0" rIns="0" tIns="0" bIns="0">
+            <a:spAutoFit/>
+          </a:bodyPr>
+          <a:lstStyle/>
+          <a:p>
+            <a:pPr algn="l">
+              <a:lnSpc>
+                <a:spcPct val="100000"/>
+              </a:lnSpc>
+            </a:pPr>
+            <a:r>
+              <a:rPr sz="1400" b="0" i="0">
+                <a:solidFill>
+                  <a:srgbClr val="0F172A"/>
+                </a:solidFill>
+                <a:latin typeface="Calibri"/>
+              </a:rPr>
+              <a:t>+31% / +18% / +16%</a:t>
+            </a:r>
+          </a:p>
+        </p:txBody>
+      </p:sp>
+      <p:sp>
+        <p:nvSpPr>
+          <p:cNvPr id="12" name="Rectangle 11"/>
+          <p:cNvSpPr/>
+          <p:nvPr/>
+        </p:nvSpPr>
+        <p:spPr>
+          <a:xfrm>
+            <a:off x="502920" y="2734056"/>
+            <a:ext cx="11155680" cy="566928"/>
+          </a:xfrm>
+          <a:prstGeom prst="rect">
+            <a:avLst/>
           </a:prstGeom>
           <a:solidFill>
             <a:srgbClr val="F1F5F9"/>
@@ -6772,14 +6448,294 @@
       </p:sp>
       <p:sp>
         <p:nvSpPr>
-          <p:cNvPr id="5" name="TextBox 4"/>
-          <p:cNvSpPr txBox="1"/>
-          <p:nvPr/>
-        </p:nvSpPr>
-        <p:spPr>
-          <a:xfrm>
-            <a:off x="740664" y="1773936"/>
-            <a:ext cx="5166360" cy="365760"/>
+          <p:cNvPr id="13" name="TextBox 12"/>
+          <p:cNvSpPr txBox="1"/>
+          <p:nvPr/>
+        </p:nvSpPr>
+        <p:spPr>
+          <a:xfrm>
+            <a:off x="685800" y="2734056"/>
+            <a:ext cx="3657600" cy="566928"/>
+          </a:xfrm>
+          <a:prstGeom prst="rect">
+            <a:avLst/>
+          </a:prstGeom>
+          <a:noFill/>
+        </p:spPr>
+        <p:txBody>
+          <a:bodyPr wrap="square" anchor="ctr" lIns="0" rIns="0" tIns="0" bIns="0">
+            <a:spAutoFit/>
+          </a:bodyPr>
+          <a:lstStyle/>
+          <a:p>
+            <a:pPr algn="l">
+              <a:lnSpc>
+                <a:spcPct val="100000"/>
+              </a:lnSpc>
+            </a:pPr>
+            <a:r>
+              <a:rPr sz="1400" b="1" i="0">
+                <a:solidFill>
+                  <a:srgbClr val="475569"/>
+                </a:solidFill>
+                <a:latin typeface="Calibri"/>
+              </a:rPr>
+              <a:t>Bengaluru</a:t>
+            </a:r>
+          </a:p>
+        </p:txBody>
+      </p:sp>
+      <p:sp>
+        <p:nvSpPr>
+          <p:cNvPr id="14" name="TextBox 13"/>
+          <p:cNvSpPr txBox="1"/>
+          <p:nvPr/>
+        </p:nvSpPr>
+        <p:spPr>
+          <a:xfrm>
+            <a:off x="4709160" y="2734056"/>
+            <a:ext cx="3200400" cy="566928"/>
+          </a:xfrm>
+          <a:prstGeom prst="rect">
+            <a:avLst/>
+          </a:prstGeom>
+          <a:noFill/>
+        </p:spPr>
+        <p:txBody>
+          <a:bodyPr wrap="square" anchor="ctr" lIns="0" rIns="0" tIns="0" bIns="0">
+            <a:spAutoFit/>
+          </a:bodyPr>
+          <a:lstStyle/>
+          <a:p>
+            <a:pPr algn="l">
+              <a:lnSpc>
+                <a:spcPct val="100000"/>
+              </a:lnSpc>
+            </a:pPr>
+            <a:r>
+              <a:rPr sz="1400" b="0" i="0">
+                <a:solidFill>
+                  <a:srgbClr val="0F172A"/>
+                </a:solidFill>
+                <a:latin typeface="Calibri"/>
+              </a:rPr>
+              <a:t>+15% / +17% / +9%</a:t>
+            </a:r>
+          </a:p>
+        </p:txBody>
+      </p:sp>
+      <p:sp>
+        <p:nvSpPr>
+          <p:cNvPr id="15" name="TextBox 14"/>
+          <p:cNvSpPr txBox="1"/>
+          <p:nvPr/>
+        </p:nvSpPr>
+        <p:spPr>
+          <a:xfrm>
+            <a:off x="8275319" y="2734056"/>
+            <a:ext cx="3200400" cy="566928"/>
+          </a:xfrm>
+          <a:prstGeom prst="rect">
+            <a:avLst/>
+          </a:prstGeom>
+          <a:noFill/>
+        </p:spPr>
+        <p:txBody>
+          <a:bodyPr wrap="square" anchor="ctr" lIns="0" rIns="0" tIns="0" bIns="0">
+            <a:spAutoFit/>
+          </a:bodyPr>
+          <a:lstStyle/>
+          <a:p>
+            <a:pPr algn="l">
+              <a:lnSpc>
+                <a:spcPct val="100000"/>
+              </a:lnSpc>
+            </a:pPr>
+            <a:r>
+              <a:rPr sz="1400" b="0" i="0">
+                <a:solidFill>
+                  <a:srgbClr val="0F172A"/>
+                </a:solidFill>
+                <a:latin typeface="Calibri"/>
+              </a:rPr>
+              <a:t>+14% / +5% / −7%</a:t>
+            </a:r>
+          </a:p>
+        </p:txBody>
+      </p:sp>
+      <p:sp>
+        <p:nvSpPr>
+          <p:cNvPr id="16" name="Rectangle 15"/>
+          <p:cNvSpPr/>
+          <p:nvPr/>
+        </p:nvSpPr>
+        <p:spPr>
+          <a:xfrm>
+            <a:off x="502920" y="3300984"/>
+            <a:ext cx="11155680" cy="566928"/>
+          </a:xfrm>
+          <a:prstGeom prst="rect">
+            <a:avLst/>
+          </a:prstGeom>
+          <a:solidFill>
+            <a:srgbClr val="FFFFFF"/>
+          </a:solidFill>
+          <a:ln w="9525">
+            <a:solidFill>
+              <a:srgbClr val="E2E8F0"/>
+            </a:solidFill>
+          </a:ln>
+          <a:effectLst/>
+        </p:spPr>
+        <p:style>
+          <a:lnRef idx="1">
+            <a:schemeClr val="accent1"/>
+          </a:lnRef>
+          <a:fillRef idx="3">
+            <a:schemeClr val="accent1"/>
+          </a:fillRef>
+          <a:effectRef idx="2">
+            <a:schemeClr val="accent1"/>
+          </a:effectRef>
+          <a:fontRef idx="minor">
+            <a:schemeClr val="lt1"/>
+          </a:fontRef>
+        </p:style>
+        <p:txBody>
+          <a:bodyPr rtlCol="0" anchor="ctr"/>
+          <a:lstStyle/>
+          <a:p>
+            <a:pPr algn="ctr"/>
+          </a:p>
+        </p:txBody>
+      </p:sp>
+      <p:sp>
+        <p:nvSpPr>
+          <p:cNvPr id="17" name="TextBox 16"/>
+          <p:cNvSpPr txBox="1"/>
+          <p:nvPr/>
+        </p:nvSpPr>
+        <p:spPr>
+          <a:xfrm>
+            <a:off x="685800" y="3300984"/>
+            <a:ext cx="3657600" cy="566928"/>
+          </a:xfrm>
+          <a:prstGeom prst="rect">
+            <a:avLst/>
+          </a:prstGeom>
+          <a:noFill/>
+        </p:spPr>
+        <p:txBody>
+          <a:bodyPr wrap="square" anchor="ctr" lIns="0" rIns="0" tIns="0" bIns="0">
+            <a:spAutoFit/>
+          </a:bodyPr>
+          <a:lstStyle/>
+          <a:p>
+            <a:pPr algn="l">
+              <a:lnSpc>
+                <a:spcPct val="100000"/>
+              </a:lnSpc>
+            </a:pPr>
+            <a:r>
+              <a:rPr sz="1400" b="1" i="0">
+                <a:solidFill>
+                  <a:srgbClr val="475569"/>
+                </a:solidFill>
+                <a:latin typeface="Calibri"/>
+              </a:rPr>
+              <a:t>Mumbai</a:t>
+            </a:r>
+          </a:p>
+        </p:txBody>
+      </p:sp>
+      <p:sp>
+        <p:nvSpPr>
+          <p:cNvPr id="18" name="TextBox 17"/>
+          <p:cNvSpPr txBox="1"/>
+          <p:nvPr/>
+        </p:nvSpPr>
+        <p:spPr>
+          <a:xfrm>
+            <a:off x="4709160" y="3300984"/>
+            <a:ext cx="3200400" cy="566928"/>
+          </a:xfrm>
+          <a:prstGeom prst="rect">
+            <a:avLst/>
+          </a:prstGeom>
+          <a:noFill/>
+        </p:spPr>
+        <p:txBody>
+          <a:bodyPr wrap="square" anchor="ctr" lIns="0" rIns="0" tIns="0" bIns="0">
+            <a:spAutoFit/>
+          </a:bodyPr>
+          <a:lstStyle/>
+          <a:p>
+            <a:pPr algn="l">
+              <a:lnSpc>
+                <a:spcPct val="100000"/>
+              </a:lnSpc>
+            </a:pPr>
+            <a:r>
+              <a:rPr sz="1400" b="0" i="0">
+                <a:solidFill>
+                  <a:srgbClr val="0F172A"/>
+                </a:solidFill>
+                <a:latin typeface="Calibri"/>
+              </a:rPr>
+              <a:t>+15% / +18% / +30%</a:t>
+            </a:r>
+          </a:p>
+        </p:txBody>
+      </p:sp>
+      <p:sp>
+        <p:nvSpPr>
+          <p:cNvPr id="19" name="TextBox 18"/>
+          <p:cNvSpPr txBox="1"/>
+          <p:nvPr/>
+        </p:nvSpPr>
+        <p:spPr>
+          <a:xfrm>
+            <a:off x="8275319" y="3300984"/>
+            <a:ext cx="3200400" cy="566928"/>
+          </a:xfrm>
+          <a:prstGeom prst="rect">
+            <a:avLst/>
+          </a:prstGeom>
+          <a:noFill/>
+        </p:spPr>
+        <p:txBody>
+          <a:bodyPr wrap="square" anchor="ctr" lIns="0" rIns="0" tIns="0" bIns="0">
+            <a:spAutoFit/>
+          </a:bodyPr>
+          <a:lstStyle/>
+          <a:p>
+            <a:pPr algn="l">
+              <a:lnSpc>
+                <a:spcPct val="100000"/>
+              </a:lnSpc>
+            </a:pPr>
+            <a:r>
+              <a:rPr sz="1400" b="0" i="0">
+                <a:solidFill>
+                  <a:srgbClr val="0F172A"/>
+                </a:solidFill>
+                <a:latin typeface="Calibri"/>
+              </a:rPr>
+              <a:t>+3% / +3% / +4%</a:t>
+            </a:r>
+          </a:p>
+        </p:txBody>
+      </p:sp>
+      <p:sp>
+        <p:nvSpPr>
+          <p:cNvPr id="20" name="TextBox 19"/>
+          <p:cNvSpPr txBox="1"/>
+          <p:nvPr/>
+        </p:nvSpPr>
+        <p:spPr>
+          <a:xfrm>
+            <a:off x="502920" y="4114800"/>
+            <a:ext cx="11155680" cy="2103120"/>
           </a:xfrm>
           <a:prstGeom prst="rect">
             <a:avLst/>
@@ -6794,31 +6750,184 @@
           <a:p>
             <a:pPr algn="l">
               <a:lnSpc>
+                <a:spcPct val="120000"/>
+              </a:lnSpc>
+              <a:spcAft>
+                <a:spcPts val="600"/>
+              </a:spcAft>
+            </a:pPr>
+            <a:r>
+              <a:rPr sz="1450" b="1" i="0">
+                <a:solidFill>
+                  <a:srgbClr val="0F172A"/>
+                </a:solidFill>
+                <a:latin typeface="Calibri"/>
+              </a:rPr>
+              <a:t>Attribution </a:t>
+            </a:r>
+            <a:r>
+              <a:rPr sz="1450" b="0" i="0">
+                <a:solidFill>
+                  <a:srgbClr val="475569"/>
+                </a:solidFill>
+                <a:latin typeface="Calibri"/>
+              </a:rPr>
+              <a:t>— LightGBM + SHAP blended with chemical-signature priors; abstains below an out-of-sample R² gate of 0.15. Cross-checked vs inventories (cosine 0.92/0.88/0.79); traffic SHAP 2.30× higher in IST rush hours with weather controlled.</a:t>
+            </a:r>
+          </a:p>
+          <a:p>
+            <a:pPr algn="l">
+              <a:lnSpc>
+                <a:spcPct val="120000"/>
+              </a:lnSpc>
+              <a:spcAft>
+                <a:spcPts val="600"/>
+              </a:spcAft>
+            </a:pPr>
+            <a:r>
+              <a:rPr sz="1450" b="1" i="0">
+                <a:solidFill>
+                  <a:srgbClr val="0F172A"/>
+                </a:solidFill>
+                <a:latin typeface="Calibri"/>
+              </a:rPr>
+              <a:t>Uncertainty </a:t>
+            </a:r>
+            <a:r>
+              <a:rPr sz="1450" b="0" i="0">
+                <a:solidFill>
+                  <a:srgbClr val="475569"/>
+                </a:solidFill>
+                <a:latin typeface="Calibri"/>
+              </a:rPr>
+              <a:t>— raw intervals under-covered (48–63% vs nominal 80%); fixed with conformalised quantile regression → 75–80% measured coverage.</a:t>
+            </a:r>
+          </a:p>
+          <a:p>
+            <a:pPr algn="l">
+              <a:lnSpc>
+                <a:spcPct val="120000"/>
+              </a:lnSpc>
+              <a:spcAft>
+                <a:spcPts val="600"/>
+              </a:spcAft>
+            </a:pPr>
+            <a:r>
+              <a:rPr sz="1450" b="1" i="0">
+                <a:solidFill>
+                  <a:srgbClr val="0F172A"/>
+                </a:solidFill>
+                <a:latin typeface="Calibri"/>
+              </a:rPr>
+              <a:t>Model selection </a:t>
+            </a:r>
+            <a:r>
+              <a:rPr sz="1450" b="0" i="0">
+                <a:solidFill>
+                  <a:srgbClr val="475569"/>
+                </a:solidFill>
+                <a:latin typeface="Calibri"/>
+              </a:rPr>
+              <a:t>— Temporal Fusion Transformer trained on GPU and rejected: LightGBM won held-out skill in every launch city. The notebook keeps the failure.</a:t>
+            </a:r>
+          </a:p>
+          <a:p>
+            <a:pPr algn="l">
+              <a:lnSpc>
+                <a:spcPct val="120000"/>
+              </a:lnSpc>
+              <a:spcAft>
+                <a:spcPts val="600"/>
+              </a:spcAft>
+            </a:pPr>
+            <a:r>
+              <a:rPr sz="1450" b="1" i="0">
+                <a:solidFill>
+                  <a:srgbClr val="0F172A"/>
+                </a:solidFill>
+                <a:latin typeface="Calibri"/>
+              </a:rPr>
+              <a:t>Satellite detection </a:t>
+            </a:r>
+            <a:r>
+              <a:rPr sz="1450" b="0" i="0">
+                <a:solidFill>
+                  <a:srgbClr val="475569"/>
+                </a:solidFill>
+                <a:latin typeface="Calibri"/>
+              </a:rPr>
+              <a:t>— currently a labelled Earth-Engine heuristic (NDVI drop → construction, FIRMS thermal → burning); the U-Net CV model is in training and drops into the same schema.</a:t>
+            </a:r>
+          </a:p>
+        </p:txBody>
+      </p:sp>
+    </p:spTree>
+  </p:cSld>
+  <p:clrMapOvr>
+    <a:masterClrMapping/>
+  </p:clrMapOvr>
+</p:sld>
+</file>
+
+<file path=ppt/slides/slide16.xml><?xml version="1.0" encoding="utf-8"?>
+<p:sld xmlns:a="http://schemas.openxmlformats.org/drawingml/2006/main" xmlns:p="http://schemas.openxmlformats.org/presentationml/2006/main" xmlns:r="http://schemas.openxmlformats.org/officeDocument/2006/relationships">
+  <p:cSld>
+    <p:spTree>
+      <p:nvGrpSpPr>
+        <p:cNvPr id="1" name=""/>
+        <p:cNvGrpSpPr/>
+        <p:nvPr/>
+      </p:nvGrpSpPr>
+      <p:grpSpPr/>
+      <p:sp>
+        <p:nvSpPr>
+          <p:cNvPr id="2" name="TextBox 1"/>
+          <p:cNvSpPr txBox="1"/>
+          <p:nvPr/>
+        </p:nvSpPr>
+        <p:spPr>
+          <a:xfrm>
+            <a:off x="502920" y="347472"/>
+            <a:ext cx="11155680" cy="320040"/>
+          </a:xfrm>
+          <a:prstGeom prst="rect">
+            <a:avLst/>
+          </a:prstGeom>
+          <a:noFill/>
+        </p:spPr>
+        <p:txBody>
+          <a:bodyPr wrap="square" anchor="t" lIns="0" rIns="0" tIns="0" bIns="0">
+            <a:spAutoFit/>
+          </a:bodyPr>
+          <a:lstStyle/>
+          <a:p>
+            <a:pPr algn="l">
+              <a:lnSpc>
                 <a:spcPct val="100000"/>
               </a:lnSpc>
             </a:pPr>
             <a:r>
-              <a:rPr sz="1650" b="1" i="0">
+              <a:rPr sz="1400" b="1" i="0">
                 <a:solidFill>
                   <a:srgbClr val="059669"/>
                 </a:solidFill>
                 <a:latin typeface="Calibri"/>
               </a:rPr>
-              <a:t>The model abstains</a:t>
-            </a:r>
-          </a:p>
-        </p:txBody>
-      </p:sp>
-      <p:sp>
-        <p:nvSpPr>
-          <p:cNvPr id="6" name="TextBox 5"/>
-          <p:cNvSpPr txBox="1"/>
-          <p:nvPr/>
-        </p:nvSpPr>
-        <p:spPr>
-          <a:xfrm>
-            <a:off x="740664" y="2157984"/>
-            <a:ext cx="5166360" cy="822960"/>
+              <a:t>A6 · HONESTY &amp; FAIRNESS</a:t>
+            </a:r>
+          </a:p>
+        </p:txBody>
+      </p:sp>
+      <p:sp>
+        <p:nvSpPr>
+          <p:cNvPr id="3" name="TextBox 2"/>
+          <p:cNvSpPr txBox="1"/>
+          <p:nvPr/>
+        </p:nvSpPr>
+        <p:spPr>
+          <a:xfrm>
+            <a:off x="502920" y="658368"/>
+            <a:ext cx="11247120" cy="777240"/>
           </a:xfrm>
           <a:prstGeom prst="rect">
             <a:avLst/>
@@ -6833,30 +6942,30 @@
           <a:p>
             <a:pPr algn="l">
               <a:lnSpc>
-                <a:spcPct val="114000"/>
-              </a:lnSpc>
-            </a:pPr>
-            <a:r>
-              <a:rPr sz="1300" b="0" i="0">
-                <a:solidFill>
-                  <a:srgbClr val="475569"/>
-                </a:solidFill>
-                <a:latin typeface="Calibri"/>
-              </a:rPr>
-              <a:t>No ML blame without out-of-sample skill; falls back to cited chemical-signature priors and says so in the UI.</a:t>
-            </a:r>
-          </a:p>
-        </p:txBody>
-      </p:sp>
-      <p:sp>
-        <p:nvSpPr>
-          <p:cNvPr id="7" name="Rounded Rectangle 6"/>
+                <a:spcPct val="100000"/>
+              </a:lnSpc>
+            </a:pPr>
+            <a:r>
+              <a:rPr sz="2800" b="1" i="0">
+                <a:solidFill>
+                  <a:srgbClr val="0F172A"/>
+                </a:solidFill>
+                <a:latin typeface="Calibri"/>
+              </a:rPr>
+              <a:t>Honest by construction</a:t>
+            </a:r>
+          </a:p>
+        </p:txBody>
+      </p:sp>
+      <p:sp>
+        <p:nvSpPr>
+          <p:cNvPr id="4" name="Rounded Rectangle 3"/>
           <p:cNvSpPr/>
           <p:nvPr/>
         </p:nvSpPr>
         <p:spPr>
           <a:xfrm>
-            <a:off x="6309359" y="1645920"/>
+            <a:off x="502920" y="1645920"/>
             <a:ext cx="5596128" cy="1371600"/>
           </a:xfrm>
           <a:prstGeom prst="roundRect">
@@ -6898,13 +7007,13 @@
       </p:sp>
       <p:sp>
         <p:nvSpPr>
-          <p:cNvPr id="8" name="TextBox 7"/>
-          <p:cNvSpPr txBox="1"/>
-          <p:nvPr/>
-        </p:nvSpPr>
-        <p:spPr>
-          <a:xfrm>
-            <a:off x="6547103" y="1773936"/>
+          <p:cNvPr id="5" name="TextBox 4"/>
+          <p:cNvSpPr txBox="1"/>
+          <p:nvPr/>
+        </p:nvSpPr>
+        <p:spPr>
+          <a:xfrm>
+            <a:off x="740664" y="1773936"/>
             <a:ext cx="5166360" cy="365760"/>
           </a:xfrm>
           <a:prstGeom prst="rect">
@@ -6930,20 +7039,20 @@
                 </a:solidFill>
                 <a:latin typeface="Calibri"/>
               </a:rPr>
-              <a:t>Health text is LLM-free</a:t>
-            </a:r>
-          </a:p>
-        </p:txBody>
-      </p:sp>
-      <p:sp>
-        <p:nvSpPr>
-          <p:cNvPr id="9" name="TextBox 8"/>
-          <p:cNvSpPr txBox="1"/>
-          <p:nvPr/>
-        </p:nvSpPr>
-        <p:spPr>
-          <a:xfrm>
-            <a:off x="6547103" y="2157984"/>
+              <a:t>The model abstains</a:t>
+            </a:r>
+          </a:p>
+        </p:txBody>
+      </p:sp>
+      <p:sp>
+        <p:nvSpPr>
+          <p:cNvPr id="6" name="TextBox 5"/>
+          <p:cNvSpPr txBox="1"/>
+          <p:nvPr/>
+        </p:nvSpPr>
+        <p:spPr>
+          <a:xfrm>
+            <a:off x="740664" y="2157984"/>
             <a:ext cx="5166360" cy="822960"/>
           </a:xfrm>
           <a:prstGeom prst="rect">
@@ -6969,20 +7078,20 @@
                 </a:solidFill>
                 <a:latin typeface="Calibri"/>
               </a:rPr>
-              <a:t>Advisories are deterministic templates in 4 languages — a language model cannot hallucinate medical advice.</a:t>
-            </a:r>
-          </a:p>
-        </p:txBody>
-      </p:sp>
-      <p:sp>
-        <p:nvSpPr>
-          <p:cNvPr id="10" name="Rounded Rectangle 9"/>
+              <a:t>No ML blame without out-of-sample skill; falls back to cited chemical-signature priors and says so in the UI.</a:t>
+            </a:r>
+          </a:p>
+        </p:txBody>
+      </p:sp>
+      <p:sp>
+        <p:nvSpPr>
+          <p:cNvPr id="7" name="Rounded Rectangle 6"/>
           <p:cNvSpPr/>
           <p:nvPr/>
         </p:nvSpPr>
         <p:spPr>
           <a:xfrm>
-            <a:off x="502920" y="3154680"/>
+            <a:off x="6309359" y="1645920"/>
             <a:ext cx="5596128" cy="1371600"/>
           </a:xfrm>
           <a:prstGeom prst="roundRect">
@@ -7024,13 +7133,13 @@
       </p:sp>
       <p:sp>
         <p:nvSpPr>
-          <p:cNvPr id="11" name="TextBox 10"/>
-          <p:cNvSpPr txBox="1"/>
-          <p:nvPr/>
-        </p:nvSpPr>
-        <p:spPr>
-          <a:xfrm>
-            <a:off x="740664" y="3282696"/>
+          <p:cNvPr id="8" name="TextBox 7"/>
+          <p:cNvSpPr txBox="1"/>
+          <p:nvPr/>
+        </p:nvSpPr>
+        <p:spPr>
+          <a:xfrm>
+            <a:off x="6547103" y="1773936"/>
             <a:ext cx="5166360" cy="365760"/>
           </a:xfrm>
           <a:prstGeom prst="rect">
@@ -7056,20 +7165,20 @@
                 </a:solidFill>
                 <a:latin typeface="Calibri"/>
               </a:rPr>
-              <a:t>Notices are drafts</a:t>
-            </a:r>
-          </a:p>
-        </p:txBody>
-      </p:sp>
-      <p:sp>
-        <p:nvSpPr>
-          <p:cNvPr id="12" name="TextBox 11"/>
-          <p:cNvSpPr txBox="1"/>
-          <p:nvPr/>
-        </p:nvSpPr>
-        <p:spPr>
-          <a:xfrm>
-            <a:off x="740664" y="3666744"/>
+              <a:t>Health text is LLM-free</a:t>
+            </a:r>
+          </a:p>
+        </p:txBody>
+      </p:sp>
+      <p:sp>
+        <p:nvSpPr>
+          <p:cNvPr id="9" name="TextBox 8"/>
+          <p:cNvSpPr txBox="1"/>
+          <p:nvPr/>
+        </p:nvSpPr>
+        <p:spPr>
+          <a:xfrm>
+            <a:off x="6547103" y="2157984"/>
             <a:ext cx="5166360" cy="822960"/>
           </a:xfrm>
           <a:prstGeom prst="rect">
@@ -7095,20 +7204,20 @@
                 </a:solidFill>
                 <a:latin typeface="Calibri"/>
               </a:rPr>
-              <a:t>Stamped 'pending officer authorisation'; never auto-sent. Dispatching starts before/after impact measurement, corrected for city drift.</a:t>
-            </a:r>
-          </a:p>
-        </p:txBody>
-      </p:sp>
-      <p:sp>
-        <p:nvSpPr>
-          <p:cNvPr id="13" name="Rounded Rectangle 12"/>
+              <a:t>Advisories are deterministic templates in 4 languages — a language model cannot hallucinate medical advice.</a:t>
+            </a:r>
+          </a:p>
+        </p:txBody>
+      </p:sp>
+      <p:sp>
+        <p:nvSpPr>
+          <p:cNvPr id="10" name="Rounded Rectangle 9"/>
           <p:cNvSpPr/>
           <p:nvPr/>
         </p:nvSpPr>
         <p:spPr>
           <a:xfrm>
-            <a:off x="6309359" y="3154680"/>
+            <a:off x="502920" y="3154680"/>
             <a:ext cx="5596128" cy="1371600"/>
           </a:xfrm>
           <a:prstGeom prst="roundRect">
@@ -7150,13 +7259,13 @@
       </p:sp>
       <p:sp>
         <p:nvSpPr>
-          <p:cNvPr id="14" name="TextBox 13"/>
-          <p:cNvSpPr txBox="1"/>
-          <p:nvPr/>
-        </p:nvSpPr>
-        <p:spPr>
-          <a:xfrm>
-            <a:off x="6547103" y="3282696"/>
+          <p:cNvPr id="11" name="TextBox 10"/>
+          <p:cNvSpPr txBox="1"/>
+          <p:nvPr/>
+        </p:nvSpPr>
+        <p:spPr>
+          <a:xfrm>
+            <a:off x="740664" y="3282696"/>
             <a:ext cx="5166360" cy="365760"/>
           </a:xfrm>
           <a:prstGeom prst="rect">
@@ -7182,20 +7291,20 @@
                 </a:solidFill>
                 <a:latin typeface="Calibri"/>
               </a:rPr>
-              <a:t>Nothing fabricated</a:t>
-            </a:r>
-          </a:p>
-        </p:txBody>
-      </p:sp>
-      <p:sp>
-        <p:nvSpPr>
-          <p:cNvPr id="15" name="TextBox 14"/>
-          <p:cNvSpPr txBox="1"/>
-          <p:nvPr/>
-        </p:nvSpPr>
-        <p:spPr>
-          <a:xfrm>
-            <a:off x="6547103" y="3666744"/>
+              <a:t>Notices are drafts</a:t>
+            </a:r>
+          </a:p>
+        </p:txBody>
+      </p:sp>
+      <p:sp>
+        <p:nvSpPr>
+          <p:cNvPr id="12" name="TextBox 11"/>
+          <p:cNvSpPr txBox="1"/>
+          <p:nvPr/>
+        </p:nvSpPr>
+        <p:spPr>
+          <a:xfrm>
+            <a:off x="740664" y="3666744"/>
             <a:ext cx="5166360" cy="822960"/>
           </a:xfrm>
           <a:prstGeom prst="rect">
@@ -7221,20 +7330,20 @@
                 </a:solidFill>
                 <a:latin typeface="Calibri"/>
               </a:rPr>
-              <a:t>Impact figures return null over invented constants; &lt;2% contributors never enter the worklist; satellite evidence is real imagery of the real site.</a:t>
-            </a:r>
-          </a:p>
-        </p:txBody>
-      </p:sp>
-      <p:sp>
-        <p:nvSpPr>
-          <p:cNvPr id="16" name="Rounded Rectangle 15"/>
+              <a:t>Stamped 'pending officer authorisation'; never auto-sent. Dispatching starts before/after impact measurement, corrected for city drift.</a:t>
+            </a:r>
+          </a:p>
+        </p:txBody>
+      </p:sp>
+      <p:sp>
+        <p:nvSpPr>
+          <p:cNvPr id="13" name="Rounded Rectangle 12"/>
           <p:cNvSpPr/>
           <p:nvPr/>
         </p:nvSpPr>
         <p:spPr>
           <a:xfrm>
-            <a:off x="502920" y="4663440"/>
+            <a:off x="6309359" y="3154680"/>
             <a:ext cx="5596128" cy="1371600"/>
           </a:xfrm>
           <a:prstGeom prst="roundRect">
@@ -7276,13 +7385,13 @@
       </p:sp>
       <p:sp>
         <p:nvSpPr>
-          <p:cNvPr id="17" name="TextBox 16"/>
-          <p:cNvSpPr txBox="1"/>
-          <p:nvPr/>
-        </p:nvSpPr>
-        <p:spPr>
-          <a:xfrm>
-            <a:off x="740664" y="4791455"/>
+          <p:cNvPr id="14" name="TextBox 13"/>
+          <p:cNvSpPr txBox="1"/>
+          <p:nvPr/>
+        </p:nvSpPr>
+        <p:spPr>
+          <a:xfrm>
+            <a:off x="6547103" y="3282696"/>
             <a:ext cx="5166360" cy="365760"/>
           </a:xfrm>
           <a:prstGeom prst="rect">
@@ -7308,20 +7417,20 @@
                 </a:solidFill>
                 <a:latin typeface="Calibri"/>
               </a:rPr>
-              <a:t>No socio-economic inputs</a:t>
-            </a:r>
-          </a:p>
-        </p:txBody>
-      </p:sp>
-      <p:sp>
-        <p:nvSpPr>
-          <p:cNvPr id="18" name="TextBox 17"/>
-          <p:cNvSpPr txBox="1"/>
-          <p:nvPr/>
-        </p:nvSpPr>
-        <p:spPr>
-          <a:xfrm>
-            <a:off x="740664" y="5175504"/>
+              <a:t>Nothing fabricated</a:t>
+            </a:r>
+          </a:p>
+        </p:txBody>
+      </p:sp>
+      <p:sp>
+        <p:nvSpPr>
+          <p:cNvPr id="15" name="TextBox 14"/>
+          <p:cNvSpPr txBox="1"/>
+          <p:nvPr/>
+        </p:nvSpPr>
+        <p:spPr>
+          <a:xfrm>
+            <a:off x="6547103" y="3666744"/>
             <a:ext cx="5166360" cy="822960"/>
           </a:xfrm>
           <a:prstGeom prst="rect">
@@ -7347,20 +7456,20 @@
                 </a:solidFill>
                 <a:latin typeface="Calibri"/>
               </a:rPr>
-              <a:t>Priority = contribution × exposure × actionability × confidence. No income or land-value feature exists anywhere in the pipeline — the fairness audit publishes what drives priority.</a:t>
-            </a:r>
-          </a:p>
-        </p:txBody>
-      </p:sp>
-      <p:sp>
-        <p:nvSpPr>
-          <p:cNvPr id="19" name="Rounded Rectangle 18"/>
+              <a:t>Impact figures return null over invented constants; &lt;2% contributors never enter the worklist; satellite evidence is real imagery of the real site.</a:t>
+            </a:r>
+          </a:p>
+        </p:txBody>
+      </p:sp>
+      <p:sp>
+        <p:nvSpPr>
+          <p:cNvPr id="16" name="Rounded Rectangle 15"/>
           <p:cNvSpPr/>
           <p:nvPr/>
         </p:nvSpPr>
         <p:spPr>
           <a:xfrm>
-            <a:off x="6309359" y="4663440"/>
+            <a:off x="502920" y="4663440"/>
             <a:ext cx="5596128" cy="1371600"/>
           </a:xfrm>
           <a:prstGeom prst="roundRect">
@@ -7402,6 +7511,132 @@
       </p:sp>
       <p:sp>
         <p:nvSpPr>
+          <p:cNvPr id="17" name="TextBox 16"/>
+          <p:cNvSpPr txBox="1"/>
+          <p:nvPr/>
+        </p:nvSpPr>
+        <p:spPr>
+          <a:xfrm>
+            <a:off x="740664" y="4791455"/>
+            <a:ext cx="5166360" cy="365760"/>
+          </a:xfrm>
+          <a:prstGeom prst="rect">
+            <a:avLst/>
+          </a:prstGeom>
+          <a:noFill/>
+        </p:spPr>
+        <p:txBody>
+          <a:bodyPr wrap="square" anchor="t" lIns="0" rIns="0" tIns="0" bIns="0">
+            <a:spAutoFit/>
+          </a:bodyPr>
+          <a:lstStyle/>
+          <a:p>
+            <a:pPr algn="l">
+              <a:lnSpc>
+                <a:spcPct val="100000"/>
+              </a:lnSpc>
+            </a:pPr>
+            <a:r>
+              <a:rPr sz="1650" b="1" i="0">
+                <a:solidFill>
+                  <a:srgbClr val="059669"/>
+                </a:solidFill>
+                <a:latin typeface="Calibri"/>
+              </a:rPr>
+              <a:t>No socio-economic inputs</a:t>
+            </a:r>
+          </a:p>
+        </p:txBody>
+      </p:sp>
+      <p:sp>
+        <p:nvSpPr>
+          <p:cNvPr id="18" name="TextBox 17"/>
+          <p:cNvSpPr txBox="1"/>
+          <p:nvPr/>
+        </p:nvSpPr>
+        <p:spPr>
+          <a:xfrm>
+            <a:off x="740664" y="5175504"/>
+            <a:ext cx="5166360" cy="822960"/>
+          </a:xfrm>
+          <a:prstGeom prst="rect">
+            <a:avLst/>
+          </a:prstGeom>
+          <a:noFill/>
+        </p:spPr>
+        <p:txBody>
+          <a:bodyPr wrap="square" anchor="t" lIns="0" rIns="0" tIns="0" bIns="0">
+            <a:spAutoFit/>
+          </a:bodyPr>
+          <a:lstStyle/>
+          <a:p>
+            <a:pPr algn="l">
+              <a:lnSpc>
+                <a:spcPct val="114000"/>
+              </a:lnSpc>
+            </a:pPr>
+            <a:r>
+              <a:rPr sz="1300" b="0" i="0">
+                <a:solidFill>
+                  <a:srgbClr val="475569"/>
+                </a:solidFill>
+                <a:latin typeface="Calibri"/>
+              </a:rPr>
+              <a:t>Priority = contribution × exposure × actionability × confidence. No income or land-value feature exists anywhere in the pipeline — the fairness audit publishes what drives priority.</a:t>
+            </a:r>
+          </a:p>
+        </p:txBody>
+      </p:sp>
+      <p:sp>
+        <p:nvSpPr>
+          <p:cNvPr id="19" name="Rounded Rectangle 18"/>
+          <p:cNvSpPr/>
+          <p:nvPr/>
+        </p:nvSpPr>
+        <p:spPr>
+          <a:xfrm>
+            <a:off x="6309359" y="4663440"/>
+            <a:ext cx="5596128" cy="1371600"/>
+          </a:xfrm>
+          <a:prstGeom prst="roundRect">
+            <a:avLst>
+              <a:gd name="adj" fmla="val 8000"/>
+            </a:avLst>
+          </a:prstGeom>
+          <a:solidFill>
+            <a:srgbClr val="F1F5F9"/>
+          </a:solidFill>
+          <a:ln w="9525">
+            <a:solidFill>
+              <a:srgbClr val="E2E8F0"/>
+            </a:solidFill>
+          </a:ln>
+          <a:effectLst/>
+        </p:spPr>
+        <p:style>
+          <a:lnRef idx="1">
+            <a:schemeClr val="accent1"/>
+          </a:lnRef>
+          <a:fillRef idx="3">
+            <a:schemeClr val="accent1"/>
+          </a:fillRef>
+          <a:effectRef idx="2">
+            <a:schemeClr val="accent1"/>
+          </a:effectRef>
+          <a:fontRef idx="minor">
+            <a:schemeClr val="lt1"/>
+          </a:fontRef>
+        </p:style>
+        <p:txBody>
+          <a:bodyPr rtlCol="0" anchor="ctr"/>
+          <a:lstStyle/>
+          <a:p>
+            <a:pPr algn="ctr"/>
+          </a:p>
+        </p:txBody>
+      </p:sp>
+      <p:sp>
+        <p:nvSpPr>
           <p:cNvPr id="20" name="TextBox 19"/>
           <p:cNvSpPr txBox="1"/>
           <p:nvPr/>
@@ -7588,7 +7823,7 @@
 </p:sld>
 </file>
 
-<file path=ppt/slides/slide16.xml><?xml version="1.0" encoding="utf-8"?>
+<file path=ppt/slides/slide17.xml><?xml version="1.0" encoding="utf-8"?>
 <p:sld xmlns:a="http://schemas.openxmlformats.org/drawingml/2006/main" xmlns:p="http://schemas.openxmlformats.org/presentationml/2006/main" xmlns:r="http://schemas.openxmlformats.org/officeDocument/2006/relationships">
   <p:cSld>
     <p:spTree>
@@ -10056,7 +10291,7 @@
                 </a:solidFill>
                 <a:latin typeface="Calibri"/>
               </a:rPr>
-              <a:t>1 · Blame map — click a cell, see who's responsible</a:t>
+              <a:t>1 · Blame map — click a cell: who's responsible, and its past year of air</a:t>
             </a:r>
           </a:p>
         </p:txBody>
@@ -13415,7 +13650,7 @@
                 </a:solidFill>
                 <a:latin typeface="Calibri"/>
               </a:rPr>
-              <a:t>A1 Architecture · A2 Six agents live · A3 Evidence dossier · A4 Citizen reach · A5 Models &amp; validation detail · A6 Honesty &amp; fairness · A7 Cost, security &amp; roadmap · A8 Ten cities</a:t>
+              <a:t>A1 Architecture · A2 Six agents live · A3 Evidence dossier · A4 Citizen reach · A5 Models &amp; validation detail · A6 Honesty &amp; fairness · A7 Cost, security &amp; roadmap · A8 Ten cities · A9 Past air</a:t>
             </a:r>
           </a:p>
         </p:txBody>

</xml_diff>

<commit_message>
docs+deck: re-measured benchmark on cleaned data (Delhi +2/+10/+9%, Mumbai +18/+19/+21%, Kolkata), landing validation rows, journey spec gated on VN_LIVE
- plausibility guard removed glitch rows from every artifact; all quoted numbers refreshed
  in BENCHMARKS, EARLY_WARNING, README, SUBMISSION, landing and deck (slide 5, A5, A11)
- Mumbai multi-season artifact added; fixtures rebuilt; PDFs rebuilt
- present-mode wrap fixes; time scrub shifts when the cell drawer is open
</commit_message>
<xml_diff>
--- a/docs/VayuNetra_Pitch.pptx
+++ b/docs/VayuNetra_Pitch.pptx
@@ -6530,7 +6530,7 @@
                 </a:solidFill>
                 <a:latin typeface="Calibri"/>
               </a:rPr>
-              <a:t>Delhi · multi-season, 208k test hrs (winter 25-26 + summer 26)</a:t>
+              <a:t>Delhi · multi-season, 207k test hrs (winter 25-26 + summer 26)</a:t>
             </a:r>
           </a:p>
         </p:txBody>
@@ -6569,7 +6569,7 @@
                 </a:solidFill>
                 <a:latin typeface="Calibri"/>
               </a:rPr>
-              <a:t>+8% / +14% / +13%</a:t>
+              <a:t>+2% / +10% / +9%</a:t>
             </a:r>
           </a:p>
         </p:txBody>
@@ -6608,7 +6608,7 @@
                 </a:solidFill>
                 <a:latin typeface="Calibri"/>
               </a:rPr>
-              <a:t>+20% / +20% / +16%</a:t>
+              <a:t>+20% / +17% / +13%</a:t>
             </a:r>
           </a:p>
         </p:txBody>
@@ -7378,7 +7378,7 @@
                 </a:solidFill>
                 <a:latin typeface="Calibri"/>
               </a:rPr>
-              <a:t>— conformalised quantile regression: 80% band measured at 78% coverage on 208k Delhi test hours; every forecast now also carries a calibrated P(&gt;120) / P(&gt;250) (Brier skill +48% / +23% vs climatology at 24 h).</a:t>
+              <a:t>— conformalised quantile regression: 80% band measured at 78% coverage on 207k Delhi test hours; every forecast now also carries a calibrated P(&gt;120) / P(&gt;250) (Brier skill +49% / +23% vs climatology at 24 h).</a:t>
             </a:r>
           </a:p>
           <a:p>
@@ -10157,7 +10157,7 @@
                 </a:solidFill>
                 <a:latin typeface="Calibri"/>
               </a:rPr>
-              <a:t>15,817</a:t>
+              <a:t>15,701</a:t>
             </a:r>
           </a:p>
         </p:txBody>
@@ -10196,7 +10196,7 @@
                 </a:solidFill>
                 <a:latin typeface="Calibri"/>
               </a:rPr>
-              <a:t>36%</a:t>
+              <a:t>35%</a:t>
             </a:r>
           </a:p>
         </p:txBody>
@@ -10274,7 +10274,7 @@
                 </a:solidFill>
                 <a:latin typeface="Calibri"/>
               </a:rPr>
-              <a:t>0.761 / 0.746</a:t>
+              <a:t>0.765 / 0.747</a:t>
             </a:r>
           </a:p>
         </p:txBody>
@@ -10313,7 +10313,7 @@
                 </a:solidFill>
                 <a:latin typeface="Calibri"/>
               </a:rPr>
-              <a:t>+48%</a:t>
+              <a:t>+49%</a:t>
             </a:r>
           </a:p>
         </p:txBody>
@@ -10352,7 +10352,7 @@
                 </a:solidFill>
                 <a:latin typeface="Calibri"/>
               </a:rPr>
-              <a:t>0.78</a:t>
+              <a:t>0.783</a:t>
             </a:r>
           </a:p>
         </p:txBody>
@@ -10476,7 +10476,7 @@
                 </a:solidFill>
                 <a:latin typeface="Calibri"/>
               </a:rPr>
-              <a:t>18,356</a:t>
+              <a:t>18,226</a:t>
             </a:r>
           </a:p>
         </p:txBody>
@@ -10593,7 +10593,7 @@
                 </a:solidFill>
                 <a:latin typeface="Calibri"/>
               </a:rPr>
-              <a:t>0.731 / 0.706</a:t>
+              <a:t>0.735 / 0.708</a:t>
             </a:r>
           </a:p>
         </p:txBody>
@@ -10632,7 +10632,7 @@
                 </a:solidFill>
                 <a:latin typeface="Calibri"/>
               </a:rPr>
-              <a:t>+44%</a:t>
+              <a:t>+43%</a:t>
             </a:r>
           </a:p>
         </p:txBody>
@@ -10671,7 +10671,7 @@
                 </a:solidFill>
                 <a:latin typeface="Calibri"/>
               </a:rPr>
-              <a:t>0.777</a:t>
+              <a:t>0.781</a:t>
             </a:r>
           </a:p>
         </p:txBody>
@@ -10795,7 +10795,7 @@
                 </a:solidFill>
                 <a:latin typeface="Calibri"/>
               </a:rPr>
-              <a:t>19,212</a:t>
+              <a:t>19,117</a:t>
             </a:r>
           </a:p>
         </p:txBody>
@@ -10912,7 +10912,7 @@
                 </a:solidFill>
                 <a:latin typeface="Calibri"/>
               </a:rPr>
-              <a:t>0.689 / 0.695</a:t>
+              <a:t>0.69 / 0.696</a:t>
             </a:r>
           </a:p>
         </p:txBody>
@@ -10990,7 +10990,7 @@
                 </a:solidFill>
                 <a:latin typeface="Calibri"/>
               </a:rPr>
-              <a:t>0.779</a:t>
+              <a:t>0.774</a:t>
             </a:r>
           </a:p>
         </p:txBody>
@@ -11069,7 +11069,7 @@
                 </a:solidFill>
                 <a:latin typeface="Calibri"/>
               </a:rPr>
-              <a:t>+8% / +14% / +13% at 24/48/72 h on 208k station-hours; winter-only -4% / +8% / +7%.</a:t>
+              <a:t>+2% / +10% / +9% at 24/48/72 h on 207k station-hours; winter-only -4% / +7% / +6%; Mumbai +18% / +19% / +21%.</a:t>
             </a:r>
           </a:p>
           <a:p>
@@ -15680,7 +15680,7 @@
                 </a:solidFill>
                 <a:latin typeface="Calibri"/>
               </a:rPr>
-              <a:t>+8 / +14 / +13% at 24/48/72 h (Delhi)</a:t>
+              <a:t>Delhi +2 / +10 / +9% · Mumbai +18 / +19 / +21%</a:t>
             </a:r>
           </a:p>
         </p:txBody>
@@ -15719,7 +15719,7 @@
                 </a:solidFill>
                 <a:latin typeface="Calibri"/>
               </a:rPr>
-              <a:t>208k station-hours, winter 25-26 + summer 26; monthly refit on trailing 90 d; vs persistence &amp; seasonal-naive (A11)</a:t>
+              <a:t>multi-season split, 90-d rolling refit, vs persistence &amp; seasonal-naive (A11)</a:t>
             </a:r>
           </a:p>
         </p:txBody>
@@ -15843,7 +15843,7 @@
                 </a:solidFill>
                 <a:latin typeface="Calibri"/>
               </a:rPr>
-              <a:t>36–38% of Very-Poor onsets, 1–3 days ahead</a:t>
+              <a:t>35–38% of Very-Poor onsets, 1–3 days ahead</a:t>
             </a:r>
           </a:p>
         </p:txBody>
@@ -16045,7 +16045,7 @@
                 </a:solidFill>
                 <a:latin typeface="Calibri"/>
               </a:rPr>
-              <a:t>conformal calibration; Brier skill +48% / +23% vs climatology</a:t>
+              <a:t>conformal calibration; Brier skill +49% / +23% vs climatology</a:t>
             </a:r>
           </a:p>
         </p:txBody>

</xml_diff>

<commit_message>
test: finale API tests, benchmark harness tests (62% coverage, CI gate 55%), CI e2e smoke job
</commit_message>
<xml_diff>
--- a/docs/VayuNetra_Pitch.pptx
+++ b/docs/VayuNetra_Pitch.pptx
@@ -1650,7 +1650,7 @@
           <a:p/>
           <a:p>
             <a:r>
-              <a:t>"Everything you just saw is measured, not asserted. Our source attribution was cross-checked against the official emission inventories — cosine similarity 0.92 for Delhi. It behaves physically: traffic's influence is 2.3 times higher in rush hours. The forecast beats the honest baseline — persistence — in every launch city. When we audited our own uncertainty bands we found them under-covering, and we fixed them with conformal calibration. And we trained a deep-learning forecaster on GPU — and rejected it, because gradient boosting won on held-out skill. We keep our failures in the repo. A hundred and eighty tests run on every push."</a:t>
+              <a:t>"Everything you just saw is measured, not asserted. Our source attribution was cross-checked against the official emission inventories — cosine similarity 0.92 for Delhi. It behaves physically: traffic's influence is 2.3 times higher in rush hours. The forecast beats the honest baseline — persistence — in every launch city. When we audited our own uncertainty bands we found them under-covering, and we fixed them with conformal calibration. And we trained a deep-learning forecaster on GPU — and rejected it, because gradient boosting won on held-out skill. We keep our failures in the repo. Nearly two hundred tests run on every push."</a:t>
             </a:r>
           </a:p>
           <a:p/>
@@ -16332,7 +16332,7 @@
                 </a:solidFill>
                 <a:latin typeface="Calibri"/>
               </a:rPr>
-              <a:t>180 backend + 6 e2e tests</a:t>
+              <a:t>196 backend + 16 e2e flows</a:t>
             </a:r>
           </a:p>
         </p:txBody>

</xml_diff>

<commit_message>
model: production forecast = LightGBM median blended with persistence (weight from the calibration tail); probability alarms as the operating point
- ml.forecast.train.blend_weight + calibrated residuals of the blended forecast (v3 rows)
- ml.eval.benchmark: served (blended) forecast is the headline, raw model kept as a column;
  probability-alarm operating points (τ 0.2–0.5) with precision/recall/onset recall
- artifacts re-run (Delhi +9/+13/+12 %, Mumbai +17/+19/+21 %, Kolkata +14/+10/+9 %; onset
  recall at P ≥ 0.3: 54/54/51 %); BENCHMARKS, EARLY_WARNING, README, SUBMISSION, landing,
  deck 5/A5/A11 and the console panel updated to the same numbers
</commit_message>
<xml_diff>
--- a/docs/VayuNetra_Pitch.pptx
+++ b/docs/VayuNetra_Pitch.pptx
@@ -1233,7 +1233,7 @@
           <a:lstStyle/>
           <a:p>
             <a:r>
-              <a:t>A11 — for 'how good is the forecast, really?' / 'can it warn before a spike?' Real CPCB data, 39 Delhi station cells, the whole 2025-26 winter as test, model retrained monthly on the trailing 90 days exactly like production. Persistence cannot see an onset by construction; we catch a third of Very-Poor onsets 1–3 days ahead. We under-predict the Severe tail and say so — that is why every forecast carries a calibrated probability, not just a point.</a:t>
+              <a:t>A11 — for 'how good is the forecast, really?' / 'can it warn before a spike?' Real CPCB data, 39 Delhi station cells, the whole 2025-26 winter as test, model retrained monthly on the trailing 90 days exactly like production. Persistence cannot see an onset by construction; alarming on the calibrated probability we catch about half of Very-Poor onsets 1–3 days ahead. We under-predict the Severe tail and say so — that is why every forecast carries a calibrated probability, not just a point.</a:t>
             </a:r>
           </a:p>
         </p:txBody>
@@ -6569,7 +6569,7 @@
                 </a:solidFill>
                 <a:latin typeface="Calibri"/>
               </a:rPr>
-              <a:t>+2% / +10% / +9%</a:t>
+              <a:t>+9% / +13% / +12%</a:t>
             </a:r>
           </a:p>
         </p:txBody>
@@ -6732,7 +6732,7 @@
                 </a:solidFill>
                 <a:latin typeface="Calibri"/>
               </a:rPr>
-              <a:t>+12% / +12% / +10%</a:t>
+              <a:t>+16% / +19% / +12%</a:t>
             </a:r>
           </a:p>
         </p:txBody>
@@ -6771,7 +6771,7 @@
                 </a:solidFill>
                 <a:latin typeface="Calibri"/>
               </a:rPr>
-              <a:t>+24% / +17% / +19%</a:t>
+              <a:t>+27% / +22% / +19%</a:t>
             </a:r>
           </a:p>
         </p:txBody>
@@ -6895,7 +6895,7 @@
                 </a:solidFill>
                 <a:latin typeface="Calibri"/>
               </a:rPr>
-              <a:t>+18% / +53% / +52%</a:t>
+              <a:t>+14% / +42% / +47%</a:t>
             </a:r>
           </a:p>
         </p:txBody>
@@ -6934,7 +6934,7 @@
                 </a:solidFill>
                 <a:latin typeface="Calibri"/>
               </a:rPr>
-              <a:t>+14% / +11% / +12%</a:t>
+              <a:t>+11% / -8% / +3%</a:t>
             </a:r>
           </a:p>
         </p:txBody>
@@ -7058,7 +7058,7 @@
                 </a:solidFill>
                 <a:latin typeface="Calibri"/>
               </a:rPr>
-              <a:t>+7% / +8% / +5%</a:t>
+              <a:t>+10% / +14% / +6%</a:t>
             </a:r>
           </a:p>
         </p:txBody>
@@ -7097,7 +7097,7 @@
                 </a:solidFill>
                 <a:latin typeface="Calibri"/>
               </a:rPr>
-              <a:t>+48% / +48% / +30%</a:t>
+              <a:t>+51% / +51% / +30%</a:t>
             </a:r>
           </a:p>
         </p:txBody>
@@ -7221,7 +7221,7 @@
                 </a:solidFill>
                 <a:latin typeface="Calibri"/>
               </a:rPr>
-              <a:t>+9% / +16% / +34%</a:t>
+              <a:t>+11% / +25% / +37%</a:t>
             </a:r>
           </a:p>
         </p:txBody>
@@ -7260,7 +7260,7 @@
                 </a:solidFill>
                 <a:latin typeface="Calibri"/>
               </a:rPr>
-              <a:t>+30% / +23% / +25%</a:t>
+              <a:t>+32% / +31% / +27%</a:t>
             </a:r>
           </a:p>
         </p:txBody>
@@ -9877,7 +9877,7 @@
                 </a:solidFill>
                 <a:latin typeface="Calibri"/>
               </a:rPr>
-              <a:t>onset recall — model</a:t>
+              <a:t>onset recall — alarm on P ≥ 0.3</a:t>
             </a:r>
           </a:p>
         </p:txBody>
@@ -9955,7 +9955,7 @@
                 </a:solidFill>
                 <a:latin typeface="Calibri"/>
               </a:rPr>
-              <a:t>alarm F1 model / persist.</a:t>
+              <a:t>alarm F1 (P ≥ 0.3) / persist.</a:t>
             </a:r>
           </a:p>
         </p:txBody>
@@ -10196,7 +10196,7 @@
                 </a:solidFill>
                 <a:latin typeface="Calibri"/>
               </a:rPr>
-              <a:t>35%</a:t>
+              <a:t>54%</a:t>
             </a:r>
           </a:p>
         </p:txBody>
@@ -10313,7 +10313,7 @@
                 </a:solidFill>
                 <a:latin typeface="Calibri"/>
               </a:rPr>
-              <a:t>+49%</a:t>
+              <a:t>+51%</a:t>
             </a:r>
           </a:p>
         </p:txBody>
@@ -10515,7 +10515,7 @@
                 </a:solidFill>
                 <a:latin typeface="Calibri"/>
               </a:rPr>
-              <a:t>38%</a:t>
+              <a:t>54%</a:t>
             </a:r>
           </a:p>
         </p:txBody>
@@ -10593,7 +10593,7 @@
                 </a:solidFill>
                 <a:latin typeface="Calibri"/>
               </a:rPr>
-              <a:t>0.735 / 0.708</a:t>
+              <a:t>0.744 / 0.708</a:t>
             </a:r>
           </a:p>
         </p:txBody>
@@ -10632,7 +10632,7 @@
                 </a:solidFill>
                 <a:latin typeface="Calibri"/>
               </a:rPr>
-              <a:t>+43%</a:t>
+              <a:t>+46%</a:t>
             </a:r>
           </a:p>
         </p:txBody>
@@ -10834,7 +10834,7 @@
                 </a:solidFill>
                 <a:latin typeface="Calibri"/>
               </a:rPr>
-              <a:t>38%</a:t>
+              <a:t>51%</a:t>
             </a:r>
           </a:p>
         </p:txBody>
@@ -10912,7 +10912,7 @@
                 </a:solidFill>
                 <a:latin typeface="Calibri"/>
               </a:rPr>
-              <a:t>0.69 / 0.696</a:t>
+              <a:t>0.725 / 0.696</a:t>
             </a:r>
           </a:p>
         </p:txBody>
@@ -10951,7 +10951,7 @@
                 </a:solidFill>
                 <a:latin typeface="Calibri"/>
               </a:rPr>
-              <a:t>+32%</a:t>
+              <a:t>+38%</a:t>
             </a:r>
           </a:p>
         </p:txBody>
@@ -11069,7 +11069,7 @@
                 </a:solidFill>
                 <a:latin typeface="Calibri"/>
               </a:rPr>
-              <a:t>+2% / +10% / +9% at 24/48/72 h on 207k station-hours; winter-only -4% / +7% / +6%; Mumbai +18% / +19% / +21%.</a:t>
+              <a:t>+9% / +13% / +12% at 24/48/72 h on 207k station-hours (served forecast = LightGBM blended with persistence; raw model alone +2 / +10 / +9%); winter-only +7% / +11% / +11%; Mumbai +16% / +19% / +21%.</a:t>
             </a:r>
           </a:p>
           <a:p>
@@ -11097,7 +11097,7 @@
                 </a:solidFill>
                 <a:latin typeface="Calibri"/>
               </a:rPr>
-              <a:t>— the Severe tail (&gt;250): we under-predict it (as the official WRF-Chem does). That is why the product speaks in calibrated probability: P(&gt;250) Brier skill +23% at 24 h.</a:t>
+              <a:t>— the Severe tail (&gt;250): the blended forecast only matches persistence there and the median alarm sees few Severe onsets (as the official WRF-Chem does). That is why the product speaks in calibrated probability: P(&gt;250) Brier skill +31% at 24 h.</a:t>
             </a:r>
           </a:p>
           <a:p>
@@ -15680,7 +15680,7 @@
                 </a:solidFill>
                 <a:latin typeface="Calibri"/>
               </a:rPr>
-              <a:t>Delhi +2 / +10 / +9% · Mumbai +18 / +19 / +21%</a:t>
+              <a:t>Delhi +9% / +13% / +12% · Mumbai +16% / +19% / +21%</a:t>
             </a:r>
           </a:p>
         </p:txBody>
@@ -15719,7 +15719,7 @@
                 </a:solidFill>
                 <a:latin typeface="Calibri"/>
               </a:rPr>
-              <a:t>multi-season split, 90-d rolling refit, vs persistence &amp; seasonal-naive (A11)</a:t>
+              <a:t>multi-season split, 90-d rolling refit; served forecast = LightGBM blended with persistence (A11)</a:t>
             </a:r>
           </a:p>
         </p:txBody>
@@ -15843,7 +15843,7 @@
                 </a:solidFill>
                 <a:latin typeface="Calibri"/>
               </a:rPr>
-              <a:t>35–38% of Very-Poor onsets, 1–3 days ahead</a:t>
+              <a:t>51–54% of Very-Poor onsets, 1–3 days ahead</a:t>
             </a:r>
           </a:p>
         </p:txBody>
@@ -15882,7 +15882,7 @@
                 </a:solidFill>
                 <a:latin typeface="Calibri"/>
               </a:rPr>
-              <a:t>persistence = 0 by construction; Severe tail under-predicted — stated (A11)</a:t>
+              <a:t>alarm on calibrated P ≥ 0.3; persistence = 0 by construction; Severe tail still weak — stated (A11)</a:t>
             </a:r>
           </a:p>
         </p:txBody>
@@ -16045,7 +16045,7 @@
                 </a:solidFill>
                 <a:latin typeface="Calibri"/>
               </a:rPr>
-              <a:t>conformal calibration; Brier skill +49% / +23% vs climatology</a:t>
+              <a:t>conformal calibration; Brier skill +51% / +31% vs climatology</a:t>
             </a:r>
           </a:p>
         </p:txBody>

</xml_diff>

<commit_message>
validation: Bengaluru attribution checked against CSTEP 2022 and Guttikunda 2019 (verified from the primary PDFs); cosine anchors re-scored
- inventory anchor for Bengaluru replaced with CSTEP §4.3.4 concentration shares and the
  2019 BBMP emission tonnages, both read from the report; Guttikunda et al. 2019 Table 5 as
  the second anchor in the doc
- ATTRIBUTION_VALIDATION: Delhi table refreshed to the 18 Aug run (dust-first, agreeing with
  TERI-ARAI summer), run-to-run movement and its cause stated; Bengaluru section; Mumbai
  status; one-number cosine summary (0.88 / 0.90 / 0.93) with anchor status
- README, landing, SUBMISSION, USER_GUIDE, demo script, notebook §10 and deck (5, A5, A12)
  carry the same numbers; deck overflow on slide 5 fixed
- notebook mojibake repaired; remaining per-person owner tags removed from READMEs,
  comments, docstrings and the stage-1 script name; doc PDFs rebuilt
</commit_message>
<xml_diff>
--- a/docs/VayuNetra_Pitch.pptx
+++ b/docs/VayuNetra_Pitch.pptx
@@ -7350,7 +7350,7 @@
                 </a:solidFill>
                 <a:latin typeface="Calibri"/>
               </a:rPr>
-              <a:t>— LightGBM + SHAP blended with chemical-signature priors; abstains below an out-of-sample R² gate of 0.15. Compared honestly with TERI-ARAI 2018 for Delhi (A12): seasonality agrees, we over-weight kerbside traffic in monsoon — stated, not hidden. Traffic SHAP 2.30× higher in IST rush hours with weather controlled.</a:t>
+              <a:t>— LightGBM + SHAP blended with chemical-signature priors; abstains below an out-of-sample R² gate of 0.15. Compared honestly with TERI-ARAI 2018 for Delhi and Guttikunda 2019 / CSTEP 2022 for Bengaluru (A12): dust-first and traffic-first rankings agree, kerbside traffic is over-read, small waste fires are invisible to FIRMS — stated, not hidden. Traffic SHAP 2.30× higher in IST rush hours with weather controlled.</a:t>
             </a:r>
           </a:p>
           <a:p>
@@ -12327,7 +12327,7 @@
                 </a:solidFill>
                 <a:latin typeface="Calibri"/>
               </a:rPr>
-              <a:t>67%</a:t>
+              <a:t>28%</a:t>
             </a:r>
           </a:p>
         </p:txBody>
@@ -12529,7 +12529,7 @@
                 </a:solidFill>
                 <a:latin typeface="Calibri"/>
               </a:rPr>
-              <a:t>13%</a:t>
+              <a:t>27%</a:t>
             </a:r>
           </a:p>
         </p:txBody>
@@ -12731,7 +12731,7 @@
                 </a:solidFill>
                 <a:latin typeface="Calibri"/>
               </a:rPr>
-              <a:t>20%</a:t>
+              <a:t>45%</a:t>
             </a:r>
           </a:p>
         </p:txBody>
@@ -13135,7 +13135,7 @@
                 </a:solidFill>
                 <a:latin typeface="Calibri"/>
               </a:rPr>
-              <a:t>25% ('transported')</a:t>
+              <a:t>14% ('transported')</a:t>
             </a:r>
           </a:p>
         </p:txBody>
@@ -13252,7 +13252,7 @@
                 </a:solidFill>
                 <a:latin typeface="Calibri"/>
               </a:rPr>
-              <a:t>Read honestly. </a:t>
+              <a:t>Read honestly. Dust-first ranking agrees with the pre-monsoon study; biomass ≈ 0 in monsoon is right and rises with FIRMS fires in Oct–Nov. We over-read kerbside traffic (arterial-road stations, NO₂/CO signatures) and book less as regional than a dispersion model — a receptor-side method sees the local signal. Bengaluru vs Guttikunda 2019: traffic 39 vs 38 %, dust 29 vs 31 %, regional 13 vs 17 %; our 'industrial' is DG sets, our biomass misses small waste fires. Rank within a cell + confidence + the R² gate drive enforcement. docs/ATTRIBUTION_VALIDATION.md</a:t>
             </a:r>
             <a:r>
               <a:rPr sz="1250" b="0" i="0">
@@ -13261,7 +13261,7 @@
                 </a:solidFill>
                 <a:latin typeface="Calibri"/>
               </a:rPr>
-              <a:t>Seasonality agrees (biomass ≈ 0 in monsoon, rises with FIRMS fires in Oct–Nov); we over-weight kerbside traffic and under-weight industry/dust vs the pre-monsoon study — stations sit on arterial roads and NO₂/CO signatures are traffic-heavy. Ranking within a cell, confidence and the R² skill gate are what drive enforcement; where the gate fails we fall back to cited priors. docs/ATTRIBUTION_VALIDATION.md</a:t>
+              <a:t/>
             </a:r>
           </a:p>
         </p:txBody>
@@ -15354,7 +15354,7 @@
                 </a:solidFill>
                 <a:latin typeface="Calibri"/>
               </a:rPr>
-              <a:t>cosine 0.92 / 0.88 / 0.79</a:t>
+              <a:t>cosine 0.88 / 0.90 / 0.93</a:t>
             </a:r>
           </a:p>
         </p:txBody>
@@ -15393,7 +15393,7 @@
                 </a:solidFill>
                 <a:latin typeface="Calibri"/>
               </a:rPr>
-              <a:t>vs SAFAR-Delhi · CSTEP-Bengaluru · Urban-Emissions Mumbai</a:t>
+              <a:t>vs SAFAR-Delhi · CSTEP-Bengaluru (verified) · Urban-Emissions Mumbai</a:t>
             </a:r>
           </a:p>
         </p:txBody>
@@ -15719,7 +15719,7 @@
                 </a:solidFill>
                 <a:latin typeface="Calibri"/>
               </a:rPr>
-              <a:t>multi-season split, 90-d rolling refit; served forecast = LightGBM blended with persistence (A11)</a:t>
+              <a:t>multi-season split, 90-d rolling refit, blended with persistence (A11)</a:t>
             </a:r>
           </a:p>
         </p:txBody>
@@ -15882,7 +15882,7 @@
                 </a:solidFill>
                 <a:latin typeface="Calibri"/>
               </a:rPr>
-              <a:t>alarm on calibrated P ≥ 0.3; persistence = 0 by construction; Severe tail still weak — stated (A11)</a:t>
+              <a:t>alarm on calibrated P ≥ 0.3; persistence = 0 by construction (A11)</a:t>
             </a:r>
           </a:p>
         </p:txBody>

</xml_diff>

<commit_message>
finale readiness: truth fixes (407 not 400; 5,495 zones; live latency chip), Hindi/Marathi review recorded, expert status stated plainly (n = 0), script tightened to 3:00 with the SAFAR/DSS bridge and a real ask, QA evidence (axe 0 violations, mobile check) committed and cited
</commit_message>
<xml_diff>
--- a/docs/VayuNetra_Pitch.pptx
+++ b/docs/VayuNetra_Pitch.pptx
@@ -524,7 +524,7 @@
           <a:lstStyle/>
           <a:p>
             <a:r>
-              <a:t>[Speaker A · 0:00] Good morning. Every Indian metro measures its air; several forecast it. Nothing acts on it. VayuNetra is the operations layer: it traces who is polluting each square kilometre, predicts the next 72 hours with calibrated probabilities, ranks where to send an inspector with cited evidence, and tells citizens in their own script — live in ten cities on zero infrastructure cost. The map behind me is live: each dot is a city's PM2.5 as of this morning.</a:t>
+              <a:t>[Speaker A · 0:00] Good morning. Every Indian metro measures its air; several forecast it. Nothing acts on it. VayuNetra is the operations layer: it traces who is polluting each square kilometre, predicts the next 72 hours with honest probabilities, ranks where to send an inspector with cited evidence, and tells citizens in their own script — live in ten cities, at zero infrastructure cost. The map behind me is live.</a:t>
             </a:r>
           </a:p>
         </p:txBody>
@@ -1644,7 +1644,7 @@
           <a:lstStyle/>
           <a:p>
             <a:r>
-              <a:t>[A · 0:55] One loop, four verbs. Trace: a hybrid of gradient boosting with SHAP and chemical-signature priors assigns blame per square-kilometre cell — and abstains when it lacks skill. Predict: a LightGBM quantile forecast, blended with persistence and conformally calibrated, so every cell carries a probability of crossing Very Poor. Act: sources ranked by contribution, people exposed, actionability and confidence, each with a Sentinel-2 image, retrieved regulation and a draft notice; the officer approves, dispatches, and closes the case with the field finding on an audit trail. Protect: templated advisories in eight scripts over app, Telegram, IVR and displays. Six agents on one graph; the compute is seconds; the human steps are timestamped.</a:t>
+              <a:t>[A · 0:55] One loop, four verbs. Trace: who is to blame in each square kilometre — and it says so where it lacks skill. Predict: the next 72 hours, with each cell's chance of turning Very Poor. Act: sites ranked by contribution, people exposed and confidence — real satellite image, the regulation, a draft notice; the officer approves, dispatches, closes the case on an audit trail. Protect: advisories in eight scripts. Six agents, one graph, seconds of compute — every human step timestamped.</a:t>
             </a:r>
           </a:p>
         </p:txBody>
@@ -1714,7 +1714,7 @@
           <a:lstStyle/>
           <a:p>
             <a:r>
-              <a:t>[A · 1:35] This is Delhi's last winter, day by day, on 39 station cells — real CPCB data. Watch the markers: those are the government's actual GRAP orders. Below each, what our forecast said 24 hours before the order was signed. Stage III on 11 November and Stage IV on 13 December: flagged a full day ahead across essentially the whole network — probability of Very Poor above 80 percent when persistence, which just repeats today, said 225 and the city hit 400. The two October orders we did not foresee, and we say so on the slide. Press R to replay.</a:t>
+              <a:t>[A · 1:35] This is Delhi's last winter, day by day, on 39 station cells — real CPCB data. Watch the markers: those are the government's actual GRAP orders. Below each, what our forecast said 24 hours before the order was signed. Stage III on 11 November and Stage IV on 13 December: flagged a full day ahead across essentially the whole network — probability of Very Poor above 80 percent when persistence, which just repeats today, said 225 and the city measured 407. The two October orders we did not foresee, and we say so on the slide. Press R to replay.</a:t>
             </a:r>
           </a:p>
         </p:txBody>
@@ -1784,7 +1784,7 @@
           <a:lstStyle/>
           <a:p>
             <a:r>
-              <a:t>[A · 2:20] Every number is measured, including the ones that hurt. Left: served forecast skill over persistence on a strict temporal split, monthly refit — Delhi plus 9, 13, 12 percent at one, two, three days; Mumbai and Kolkata similar. Middle: of the clean-to-Very-Poor onsets, our calibrated alarm catches about half one to three days ahead; persistence catches zero by construction. Right: the probabilities are honest — the reliability curve sits on the diagonal, the 80 percent band covers 78 percent of more than two hundred thousand held-out hours. Attribution is checked bucket by bucket against TERI-ARAI and Guttikunda; agreements and disagreements both published. Now, the product itself.</a:t>
+              <a:t>[A · 2:20] Every number is measured — including the ones that hurt. Skill over persistence on a strict temporal split: Delhi plus 9, 13, 12 percent at one, two, three days. Of the clean-to-Very-Poor onsets, our calibrated alarm catches about half, days ahead — persistence catches none. The probabilities are honest: the reliability curve sits on the diagonal. Attribution is checked against the published studies — disagreements on the record. SAFAR and the DSS forecast the air; nothing turns a forecast into a traced, cited, delivered, closed action. We do — here it is. (hand over)</a:t>
             </a:r>
           </a:p>
         </p:txBody>
@@ -1994,7 +1994,7 @@
           <a:lstStyle/>
           <a:p>
             <a:r>
-              <a:t>[B · 7:30] India measures. India forecasts. VayuNetra operates — traced, predicted, cited, delivered, closed. In seconds of compute, in eight scripts, for zero rupees today and 2,700 a month for the whole NCAP list. It is live right now at vayunetra-aqi.vercel.app; the QR takes you there. Thank you — we would love your hardest questions.</a:t>
+              <a:t>[B · 7:30] India measures. India forecasts. VayuNetra operates — traced, predicted, cited, delivered, closed. In seconds, in eight scripts, for zero rupees today and 2,700 a month for every NCAP city. It is live now — the QR takes you there. We are ready to run it for the first city that says yes. Thank you.</a:t>
             </a:r>
           </a:p>
         </p:txBody>

</xml_diff>

<commit_message>
pitch script: verbatim lines for every slide and every demo stop (labels match the UI), timings, stage directions, verbatim Q&A; deck notes synced
</commit_message>
<xml_diff>
--- a/docs/VayuNetra_Pitch.pptx
+++ b/docs/VayuNetra_Pitch.pptx
@@ -524,7 +524,7 @@
           <a:lstStyle/>
           <a:p>
             <a:r>
-              <a:t>[Speaker A · 0:00] Good morning. Every Indian metro measures its air; several forecast it. Nothing acts on it. VayuNetra is the operations layer: it traces who is polluting each square kilometre, predicts the next 72 hours with honest probabilities, ranks where to send an inspector with cited evidence, and tells citizens in their own script — live in ten cities, at zero infrastructure cost. The map behind me is live.</a:t>
+              <a:t>[A · 0:00] Good morning. Every Indian metro measures its air; several forecast it. Nothing acts on it. VayuNetra is the operations layer: it traces who is polluting each square kilometre, predicts the next 72 hours with honest probabilities, ranks where to send an inspector with cited evidence, and tells citizens in their own script — live in ten cities, at zero infrastructure cost. The map behind me is live.</a:t>
             </a:r>
           </a:p>
         </p:txBody>
@@ -1294,7 +1294,7 @@
           <a:lstStyle/>
           <a:p>
             <a:r>
-              <a:t>[A · 0:25] The data exists. 900-plus CAAQMS stations, satellites overhead. And 1.67 million Indians still die early each year from air pollution. Why? Because a reading turns red and then nothing happens: no system tells a city officer who is polluting this square kilometre right now, what the air will do tomorrow, or where to send inspectors first. The CAG found only 31 percent of monitored cities have any response protocol at all. Cities don't need another dashboard. They need the layer that turns a reading into an intervention.</a:t>
+              <a:t>[A · 0:25] The data exists — nine hundred CAAQMS stations, satellites overhead — and 1.67 million Indians still die early each year. Why? A reading turns red and nothing happens: no system tells an officer who is polluting this square kilometre now, what the air does tomorrow, where to send inspectors first. The CAG found 31 percent of monitored cities have any response protocol at all. Cities don't need another dashboard; they need the layer that turns a reading into an intervention.</a:t>
             </a:r>
           </a:p>
         </p:txBody>
@@ -1714,7 +1714,7 @@
           <a:lstStyle/>
           <a:p>
             <a:r>
-              <a:t>[A · 1:35] This is Delhi's last winter, day by day, on 39 station cells — real CPCB data. Watch the markers: those are the government's actual GRAP orders. Below each, what our forecast said 24 hours before the order was signed. Stage III on 11 November and Stage IV on 13 December: flagged a full day ahead across essentially the whole network — probability of Very Poor above 80 percent when persistence, which just repeats today, said 225 and the city measured 407. The two October orders we did not foresee, and we say so on the slide. Press R to replay.</a:t>
+              <a:t>[A · 1:35 — say the first sentence, then silence for the 9-second replay, then continue] This is Delhi's last winter, day by day, on 39 station cells — real CPCB data. The markers are the government's actual GRAP orders. Under each: what our forecast said 24 hours before the order was signed. Stage III on 11 November and Stage IV on 13 December — flagged a full day ahead across essentially the whole network, probability above 80 percent, when persistence said 225 and the city measured 407. The two October orders we did not foresee — and it says so on the slide.</a:t>
             </a:r>
           </a:p>
         </p:txBody>
@@ -1854,7 +1854,7 @@
           <a:lstStyle/>
           <a:p>
             <a:r>
-              <a:t>[Speaker B · 3:00 → 7:00] Press D. Live console, Delhi, this morning. (1) Morning brief: city mean vs yesterday, where the air is about to turn, the top three actions — PDF, send to Telegram. (2) Blame map: click the worst hexagon → cell story: sources, SHAP drivers, the R² gate, 72-h forecast with P(Very Poor). (3) Worklist: open the evidence dossier — the real Sentinel-2 image, retrieved regulation, draft notice PDF; Approve → Dispatch (tracking arms) → Close case with a finding → History shows who did what, when. (4) Advisories: switch to Hindi, then Tamil — own scripts; Telegram bot live. (5) Forecast: validation card and 'Real interventions, in hindsight'. (6) Cities: ten on one scoreboard, click Mumbai. Esc back. Total 4 minutes.</a:t>
+              <a:t>[B · 3:00 → 7:00 — press D] STOP 1: This is Delhi, right now. The Morning brief is the one page a commissioner reads: the city mean against yesterday, where the air is about to turn — with the probability, not a guess — the top three actions with their notice links, and yesterday's dispatches. One click gives the PDF; one click sends it to every Telegram subscriber. Nothing on this page is written by a language model — every line is a template over stored numbers. STOP 2: Every hexagon is a square kilometre. This one: who is to blame — the sources, the SHAP drivers that moved the number, and the model's own out-of-sample R². Where it lacks skill it says so and falls back to cited chemical-signature priors, in amber. Below: the 72-hour forecast for this cell with the calibrated probability of Very Poor. Click any other cell — same story, its own numbers. STOP 3: The worklist ranks sources by contribution, people exposed, actionability and confidence — nothing under two percent gets in. Open the dossier: the real Sentinel-2 image of this site, the regulation retrieved verbatim — GRAP only where it legally binds, CPCB norms and NCAP elsewhere — and a draft notice with the projected effect of compliance. Stamped pending officer authorisation. Never auto-sent. STOP 4: The officer approves — it lands in the ward's field queue. Dispatches — the cell's seven-day baseline freezes and the before/after measurement is armed automatically. Closes the case with the field finding. And History: who did what, when, from what to what. That trail survives the nightly run and even the deletion of the record. This is the audit trail a court asks for. STOP 5: The same advisory in the reader's own script — Hindi, then Tamil — templated by design, so it cannot hallucinate medical advice. It goes out over the app, a live Telegram bot, an IVR line with a Hindi voice, and public display boards, targeted at five and a half thousand vulnerability-scored zones: hospitals, schools, elder care, outdoor work. STOP 6: The benchmark you saw on the slide lives here, per city, recomputed from the artifact — negatives included. And the winter replay: every GRAP order links to its government release, with what we carried a day before, and a weather-normalised check of whether the air changed. Where the honest answer is 'no detectable change', it says no. STOP 7: Ten cities on one scoreboard, one engine, one configuration file each — click Mumbai and the whole console follows: its own sources, its own forecast, its own worklist, its own languages. (Esc → slide 7)</a:t>
             </a:r>
           </a:p>
         </p:txBody>
@@ -1924,7 +1924,7 @@
           <a:lstStyle/>
           <a:p>
             <a:r>
-              <a:t>[B · 7:00] Built to deploy, not to demo. Ten cities live, one YAML per city, no per-city code; seven metros were onboarded that way in a week. We measured what a city costs: about 0.2 megabytes of readings a day, one row per reading, raw kept 180 days then archived. Free tier is sized for exactly this deployment; all 131 NCAP cities would run for about 2,700 rupees a month. Every dispatched action is tracked against its own cell and exported PRANA-ready, so we feed the official system rather than compete with it.</a:t>
+              <a:t>[B · 7:00] Built to deploy, not to demo. Ten cities live, one YAML per city, no per-city code; seven metros onboarded in a week. We measured what a city costs — 0.2 megabytes of readings a day, one row per reading, 180-day retention with an archive: the free tier is sized for this deployment; all 131 NCAP cities would run for about ₹2,700 a month. Every dispatched action is tracked against its own cell and exported PRANA-ready — we feed the official system, we don't compete with it.</a:t>
             </a:r>
           </a:p>
         </p:txBody>

</xml_diff>